<commit_message>
Update thesis slide deck template
Co-Authored-By: Claude Sonnet 5 <noreply@anthropic.com>
</commit_message>
<xml_diff>
--- a/thesis_new_template.pptx
+++ b/thesis_new_template.pptx
@@ -5,7 +5,7 @@
     <p:sldMasterId id="2147483648" r:id="rId1"/>
   </p:sldMasterIdLst>
   <p:notesMasterIdLst>
-    <p:notesMasterId r:id="rId25"/>
+    <p:notesMasterId r:id="rId28"/>
   </p:notesMasterIdLst>
   <p:sldIdLst>
     <p:sldId id="256" r:id="rId2"/>
@@ -20,18 +20,20 @@
     <p:sldId id="289" r:id="rId11"/>
     <p:sldId id="269" r:id="rId12"/>
     <p:sldId id="287" r:id="rId13"/>
-    <p:sldId id="291" r:id="rId31"/>
-    <p:sldId id="290" r:id="rId30"/>
-    <p:sldId id="285" r:id="rId14"/>
-    <p:sldId id="266" r:id="rId16"/>
-    <p:sldId id="273" r:id="rId17"/>
-    <p:sldId id="274" r:id="rId18"/>
-    <p:sldId id="275" r:id="rId19"/>
-    <p:sldId id="277" r:id="rId20"/>
-    <p:sldId id="280" r:id="rId21"/>
-    <p:sldId id="281" r:id="rId22"/>
-    <p:sldId id="282" r:id="rId23"/>
-    <p:sldId id="283" r:id="rId24"/>
+    <p:sldId id="291" r:id="rId14"/>
+    <p:sldId id="290" r:id="rId15"/>
+    <p:sldId id="285" r:id="rId16"/>
+    <p:sldId id="266" r:id="rId17"/>
+    <p:sldId id="273" r:id="rId18"/>
+    <p:sldId id="274" r:id="rId19"/>
+    <p:sldId id="275" r:id="rId20"/>
+    <p:sldId id="277" r:id="rId21"/>
+    <p:sldId id="280" r:id="rId22"/>
+    <p:sldId id="281" r:id="rId23"/>
+    <p:sldId id="282" r:id="rId24"/>
+    <p:sldId id="283" r:id="rId25"/>
+    <p:sldId id="293" r:id="rId26"/>
+    <p:sldId id="292" r:id="rId27"/>
   </p:sldIdLst>
   <p:sldSz cx="12192000" cy="6858000"/>
   <p:notesSz cx="6858000" cy="9144000"/>
@@ -337,6 +339,13 @@
           </p:nvPr>
         </p:nvSpPr>
         <p:spPr/>
+        <p:txBody>
+          <a:bodyPr/>
+          <a:lstStyle/>
+          <a:p>
+            <a:endParaRPr lang="zh-TW" altLang="en-US"/>
+          </a:p>
+        </p:txBody>
       </p:sp>
       <p:sp>
         <p:nvSpPr>
@@ -412,6 +421,13 @@
           </p:nvPr>
         </p:nvSpPr>
         <p:spPr/>
+        <p:txBody>
+          <a:bodyPr/>
+          <a:lstStyle/>
+          <a:p>
+            <a:endParaRPr lang="zh-TW" altLang="en-US"/>
+          </a:p>
+        </p:txBody>
       </p:sp>
       <p:sp>
         <p:nvSpPr>
@@ -487,6 +503,13 @@
           </p:nvPr>
         </p:nvSpPr>
         <p:spPr/>
+        <p:txBody>
+          <a:bodyPr/>
+          <a:lstStyle/>
+          <a:p>
+            <a:endParaRPr lang="zh-TW" altLang="en-US"/>
+          </a:p>
+        </p:txBody>
       </p:sp>
       <p:sp>
         <p:nvSpPr>
@@ -567,6 +590,13 @@
           </p:nvPr>
         </p:nvSpPr>
         <p:spPr/>
+        <p:txBody>
+          <a:bodyPr/>
+          <a:lstStyle/>
+          <a:p>
+            <a:endParaRPr lang="zh-TW" altLang="en-US"/>
+          </a:p>
+        </p:txBody>
       </p:sp>
       <p:sp>
         <p:nvSpPr>
@@ -642,6 +672,13 @@
           </p:nvPr>
         </p:nvSpPr>
         <p:spPr/>
+        <p:txBody>
+          <a:bodyPr/>
+          <a:lstStyle/>
+          <a:p>
+            <a:endParaRPr lang="zh-TW" altLang="en-US"/>
+          </a:p>
+        </p:txBody>
       </p:sp>
       <p:sp>
         <p:nvSpPr>
@@ -717,6 +754,13 @@
           </p:nvPr>
         </p:nvSpPr>
         <p:spPr/>
+        <p:txBody>
+          <a:bodyPr/>
+          <a:lstStyle/>
+          <a:p>
+            <a:endParaRPr lang="zh-TW" altLang="en-US"/>
+          </a:p>
+        </p:txBody>
       </p:sp>
       <p:sp>
         <p:nvSpPr>
@@ -792,6 +836,13 @@
           </p:nvPr>
         </p:nvSpPr>
         <p:spPr/>
+        <p:txBody>
+          <a:bodyPr/>
+          <a:lstStyle/>
+          <a:p>
+            <a:endParaRPr lang="zh-TW" altLang="en-US"/>
+          </a:p>
+        </p:txBody>
       </p:sp>
       <p:sp>
         <p:nvSpPr>
@@ -867,6 +918,13 @@
           </p:nvPr>
         </p:nvSpPr>
         <p:spPr/>
+        <p:txBody>
+          <a:bodyPr/>
+          <a:lstStyle/>
+          <a:p>
+            <a:endParaRPr lang="zh-TW" altLang="en-US"/>
+          </a:p>
+        </p:txBody>
       </p:sp>
       <p:sp>
         <p:nvSpPr>
@@ -942,6 +1000,13 @@
           </p:nvPr>
         </p:nvSpPr>
         <p:spPr/>
+        <p:txBody>
+          <a:bodyPr/>
+          <a:lstStyle/>
+          <a:p>
+            <a:endParaRPr lang="zh-TW" altLang="en-US"/>
+          </a:p>
+        </p:txBody>
       </p:sp>
       <p:sp>
         <p:nvSpPr>
@@ -1017,6 +1082,13 @@
           </p:nvPr>
         </p:nvSpPr>
         <p:spPr/>
+        <p:txBody>
+          <a:bodyPr/>
+          <a:lstStyle/>
+          <a:p>
+            <a:endParaRPr lang="zh-TW" altLang="en-US"/>
+          </a:p>
+        </p:txBody>
       </p:sp>
       <p:sp>
         <p:nvSpPr>
@@ -1092,6 +1164,13 @@
           </p:nvPr>
         </p:nvSpPr>
         <p:spPr/>
+        <p:txBody>
+          <a:bodyPr/>
+          <a:lstStyle/>
+          <a:p>
+            <a:endParaRPr lang="zh-TW" altLang="en-US"/>
+          </a:p>
+        </p:txBody>
       </p:sp>
       <p:sp>
         <p:nvSpPr>
@@ -1167,6 +1246,13 @@
           </p:nvPr>
         </p:nvSpPr>
         <p:spPr/>
+        <p:txBody>
+          <a:bodyPr/>
+          <a:lstStyle/>
+          <a:p>
+            <a:endParaRPr lang="zh-TW" altLang="en-US"/>
+          </a:p>
+        </p:txBody>
       </p:sp>
       <p:sp>
         <p:nvSpPr>
@@ -1242,6 +1328,13 @@
           </p:nvPr>
         </p:nvSpPr>
         <p:spPr/>
+        <p:txBody>
+          <a:bodyPr/>
+          <a:lstStyle/>
+          <a:p>
+            <a:endParaRPr lang="zh-TW" altLang="en-US"/>
+          </a:p>
+        </p:txBody>
       </p:sp>
       <p:sp>
         <p:nvSpPr>
@@ -1282,6 +1375,117 @@
         </p:txBody>
       </p:sp>
     </p:spTree>
+  </p:cSld>
+  <p:clrMapOvr>
+    <a:masterClrMapping/>
+  </p:clrMapOvr>
+</p:notes>
+</file>
+
+<file path=ppt/notesSlides/notesSlide21.xml><?xml version="1.0" encoding="utf-8"?>
+<p:notes xmlns:a="http://schemas.openxmlformats.org/drawingml/2006/main" xmlns:r="http://schemas.openxmlformats.org/officeDocument/2006/relationships" xmlns:p="http://schemas.openxmlformats.org/presentationml/2006/main">
+  <p:cSld>
+    <p:spTree>
+      <p:nvGrpSpPr>
+        <p:cNvPr id="1" name="">
+          <a:extLst>
+            <a:ext uri="{FF2B5EF4-FFF2-40B4-BE49-F238E27FC236}">
+              <a16:creationId xmlns:a16="http://schemas.microsoft.com/office/drawing/2014/main" id="{C7C28AFD-031B-0436-DE48-43D141BD1D37}"/>
+            </a:ext>
+          </a:extLst>
+        </p:cNvPr>
+        <p:cNvGrpSpPr/>
+        <p:nvPr/>
+      </p:nvGrpSpPr>
+      <p:grpSpPr>
+        <a:xfrm>
+          <a:off x="0" y="0"/>
+          <a:ext cx="0" cy="0"/>
+          <a:chOff x="0" y="0"/>
+          <a:chExt cx="0" cy="0"/>
+        </a:xfrm>
+      </p:grpSpPr>
+      <p:sp>
+        <p:nvSpPr>
+          <p:cNvPr id="2" name="Slide Image Placeholder 1">
+            <a:extLst>
+              <a:ext uri="{FF2B5EF4-FFF2-40B4-BE49-F238E27FC236}">
+                <a16:creationId xmlns:a16="http://schemas.microsoft.com/office/drawing/2014/main" id="{E893E3A4-B1A7-2C29-A3BB-1AC7E6D387C9}"/>
+              </a:ext>
+            </a:extLst>
+          </p:cNvPr>
+          <p:cNvSpPr>
+            <a:spLocks noGrp="1" noRot="1" noChangeAspect="1"/>
+          </p:cNvSpPr>
+          <p:nvPr>
+            <p:ph type="sldImg"/>
+          </p:nvPr>
+        </p:nvSpPr>
+        <p:spPr/>
+        <p:txBody>
+          <a:bodyPr/>
+          <a:lstStyle/>
+          <a:p>
+            <a:endParaRPr lang="zh-TW" altLang="en-US"/>
+          </a:p>
+        </p:txBody>
+      </p:sp>
+      <p:sp>
+        <p:nvSpPr>
+          <p:cNvPr id="3" name="Notes Placeholder 2">
+            <a:extLst>
+              <a:ext uri="{FF2B5EF4-FFF2-40B4-BE49-F238E27FC236}">
+                <a16:creationId xmlns:a16="http://schemas.microsoft.com/office/drawing/2014/main" id="{160C6BEB-B163-351B-D7A5-C9DE472754D5}"/>
+              </a:ext>
+            </a:extLst>
+          </p:cNvPr>
+          <p:cNvSpPr>
+            <a:spLocks noGrp="1"/>
+          </p:cNvSpPr>
+          <p:nvPr>
+            <p:ph type="body" idx="1"/>
+          </p:nvPr>
+        </p:nvSpPr>
+        <p:spPr/>
+        <p:txBody>
+          <a:bodyPr/>
+          <a:lstStyle/>
+          <a:p>
+            <a:endParaRPr/>
+          </a:p>
+        </p:txBody>
+      </p:sp>
+      <p:sp>
+        <p:nvSpPr>
+          <p:cNvPr id="4" name="Slide Number Placeholder 3">
+            <a:extLst>
+              <a:ext uri="{FF2B5EF4-FFF2-40B4-BE49-F238E27FC236}">
+                <a16:creationId xmlns:a16="http://schemas.microsoft.com/office/drawing/2014/main" id="{6292EBE5-E60A-E884-12FE-D8E2CA7D7928}"/>
+              </a:ext>
+            </a:extLst>
+          </p:cNvPr>
+          <p:cNvSpPr>
+            <a:spLocks noGrp="1"/>
+          </p:cNvSpPr>
+          <p:nvPr>
+            <p:ph type="sldNum" idx="5"/>
+          </p:nvPr>
+        </p:nvSpPr>
+        <p:spPr/>
+        <p:txBody>
+          <a:bodyPr/>
+          <a:lstStyle/>
+          <a:p>
+            <a:endParaRPr/>
+          </a:p>
+        </p:txBody>
+      </p:sp>
+    </p:spTree>
+    <p:extLst>
+      <p:ext uri="{BB962C8B-B14F-4D97-AF65-F5344CB8AC3E}">
+        <p14:creationId xmlns:p14="http://schemas.microsoft.com/office/powerpoint/2010/main" val="267916886"/>
+      </p:ext>
+    </p:extLst>
   </p:cSld>
   <p:clrMapOvr>
     <a:masterClrMapping/>
@@ -1317,6 +1521,13 @@
           </p:nvPr>
         </p:nvSpPr>
         <p:spPr/>
+        <p:txBody>
+          <a:bodyPr/>
+          <a:lstStyle/>
+          <a:p>
+            <a:endParaRPr lang="zh-TW" altLang="en-US"/>
+          </a:p>
+        </p:txBody>
       </p:sp>
       <p:sp>
         <p:nvSpPr>
@@ -1392,6 +1603,13 @@
           </p:nvPr>
         </p:nvSpPr>
         <p:spPr/>
+        <p:txBody>
+          <a:bodyPr/>
+          <a:lstStyle/>
+          <a:p>
+            <a:endParaRPr lang="zh-TW" altLang="en-US"/>
+          </a:p>
+        </p:txBody>
       </p:sp>
       <p:sp>
         <p:nvSpPr>
@@ -1467,6 +1685,13 @@
           </p:nvPr>
         </p:nvSpPr>
         <p:spPr/>
+        <p:txBody>
+          <a:bodyPr/>
+          <a:lstStyle/>
+          <a:p>
+            <a:endParaRPr lang="zh-TW" altLang="en-US"/>
+          </a:p>
+        </p:txBody>
       </p:sp>
       <p:sp>
         <p:nvSpPr>
@@ -1542,6 +1767,13 @@
           </p:nvPr>
         </p:nvSpPr>
         <p:spPr/>
+        <p:txBody>
+          <a:bodyPr/>
+          <a:lstStyle/>
+          <a:p>
+            <a:endParaRPr lang="zh-TW" altLang="en-US"/>
+          </a:p>
+        </p:txBody>
       </p:sp>
       <p:sp>
         <p:nvSpPr>
@@ -1619,6 +1851,13 @@
           </p:nvPr>
         </p:nvSpPr>
         <p:spPr/>
+        <p:txBody>
+          <a:bodyPr/>
+          <a:lstStyle/>
+          <a:p>
+            <a:endParaRPr lang="zh-TW" altLang="en-US"/>
+          </a:p>
+        </p:txBody>
       </p:sp>
       <p:sp>
         <p:nvSpPr>
@@ -1694,6 +1933,13 @@
           </p:nvPr>
         </p:nvSpPr>
         <p:spPr/>
+        <p:txBody>
+          <a:bodyPr/>
+          <a:lstStyle/>
+          <a:p>
+            <a:endParaRPr lang="zh-TW" altLang="en-US"/>
+          </a:p>
+        </p:txBody>
       </p:sp>
       <p:sp>
         <p:nvSpPr>
@@ -1769,6 +2015,13 @@
           </p:nvPr>
         </p:nvSpPr>
         <p:spPr/>
+        <p:txBody>
+          <a:bodyPr/>
+          <a:lstStyle/>
+          <a:p>
+            <a:endParaRPr lang="zh-TW" altLang="en-US"/>
+          </a:p>
+        </p:txBody>
       </p:sp>
       <p:sp>
         <p:nvSpPr>
@@ -9437,8 +9690,20 @@
           <a:lstStyle/>
           <a:p>
             <a:r>
-              <a:rPr sz="4000"/>
-              <a:t>AoA-Assisted Dynamic RTS Threshold Adaptation for Hidden-Node Risk Mitigation in Commodity Wi-Fi APs</a:t>
+              <a:rPr sz="4000" dirty="0" err="1"/>
+              <a:t>AoA</a:t>
+            </a:r>
+            <a:r>
+              <a:rPr sz="4000" dirty="0"/>
+              <a:t>-Assisted Dynamic RTS Threshold Adaptation for Hidden-Node Risk Mitigation in</a:t>
+            </a:r>
+            <a:r>
+              <a:rPr lang="en-US" sz="4000" dirty="0"/>
+              <a:t> </a:t>
+            </a:r>
+            <a:r>
+              <a:rPr sz="4000" dirty="0"/>
+              <a:t>Wi-Fi</a:t>
             </a:r>
           </a:p>
         </p:txBody>
@@ -9574,8 +9839,8 @@
           </a:p>
         </p:txBody>
       </p:sp>
-      <mc:AlternateContent xmlns:mc="http://schemas.openxmlformats.org/markup-compatibility/2006">
-        <mc:Choice xmlns:a14="http://schemas.microsoft.com/office/drawing/2010/main" Requires="a14">
+      <mc:AlternateContent xmlns:mc="http://schemas.openxmlformats.org/markup-compatibility/2006" xmlns:a14="http://schemas.microsoft.com/office/drawing/2010/main">
+        <mc:Choice Requires="a14">
           <p:sp>
             <p:nvSpPr>
               <p:cNvPr id="3" name="內容版面配置區 2">
@@ -9626,7 +9891,7 @@
                     <m:sSup>
                       <m:sSupPr>
                         <m:ctrlPr>
-                          <a:rPr lang="en-US" altLang="zh-TW" i="1" dirty="0" smtClean="0">
+                          <a:rPr lang="en-US" altLang="zh-TW" b="0" i="1" dirty="0" smtClean="0">
                             <a:latin typeface="Cambria Math" panose="02040503050406030204" pitchFamily="18" charset="0"/>
                           </a:rPr>
                         </m:ctrlPr>
@@ -9698,7 +9963,7 @@
             </p:txBody>
           </p:sp>
         </mc:Choice>
-        <mc:Fallback>
+        <mc:Fallback xmlns="">
           <p:sp>
             <p:nvSpPr>
               <p:cNvPr id="3" name="內容版面配置區 2">
@@ -9869,33 +10134,32 @@
           <a:bodyPr/>
           <a:lstStyle/>
           <a:p>
-            <a:pPr/>
-            <a:r>
+            <a:r>
+              <a:rPr dirty="0"/>
               <a:t>Antennas never observe angles directly - only phase differences of the arriving signal across the array</a:t>
             </a:r>
-            <a:endParaRPr dirty="0"/>
-          </a:p>
-          <a:p>
-            <a:pPr/>
-            <a:r>
+          </a:p>
+          <a:p>
+            <a:r>
+              <a:rPr dirty="0"/>
               <a:t>Spatial spectrum estimation scores every candidate direction; a peak means a path likely arrives from that angle</a:t>
             </a:r>
           </a:p>
           <a:p>
-            <a:pPr/>
-            <a:r>
+            <a:r>
+              <a:rPr dirty="0"/>
               <a:t>Indoor multipath yields multiple peaks: the direct path plus reflected paths</a:t>
             </a:r>
           </a:p>
           <a:p>
-            <a:pPr/>
-            <a:r>
+            <a:r>
+              <a:rPr dirty="0"/>
               <a:t>Reading each peak as one propagation path's AoA is the key step for Wi-Fi localization</a:t>
             </a:r>
           </a:p>
           <a:p>
-            <a:pPr/>
-            <a:r>
+            <a:r>
+              <a:rPr dirty="0"/>
               <a:t>To compare directions, we first need to know what each direction looks like in phase</a:t>
             </a:r>
           </a:p>
@@ -9976,7 +10240,7 @@
           <p:cNvPr id="2" name="標題 1">
             <a:extLst>
               <a:ext uri="{FF2B5EF4-FFF2-40B4-BE49-F238E27FC236}">
-                <a16:creationId xmlns:a16="http://schemas.microsoft.com/office/drawing/2014/main" id="{27A3B284-1CEC-47E9-98B8-BA58ABCB5210}"/>
+                <a16:creationId xmlns:a16="http://schemas.microsoft.com/office/drawing/2014/main" id="{155386B2-4D86-418A-841B-0E5321F04EE6}"/>
               </a:ext>
             </a:extLst>
           </p:cNvPr>
@@ -9994,9 +10258,9 @@
           <a:p>
             <a:r>
               <a:rPr lang="en-US" altLang="zh-TW" dirty="0"/>
-              <a:t>Classic Beamforming Hits a Resolution Wall</a:t>
-            </a:r>
-            <a:endParaRPr b="1" dirty="0"/>
+              <a:t>Steering Vector Encodes Angle-Dependent Phase</a:t>
+            </a:r>
+            <a:endParaRPr lang="zh-TW" altLang="en-US" dirty="0"/>
           </a:p>
         </p:txBody>
       </p:sp>
@@ -10005,7 +10269,7 @@
           <p:cNvPr id="3" name="內容版面配置區 2">
             <a:extLst>
               <a:ext uri="{FF2B5EF4-FFF2-40B4-BE49-F238E27FC236}">
-                <a16:creationId xmlns:a16="http://schemas.microsoft.com/office/drawing/2014/main" id="{85EB7868-0B10-4ADE-BF08-3CE42A258785}"/>
+                <a16:creationId xmlns:a16="http://schemas.microsoft.com/office/drawing/2014/main" id="{D6A93578-5499-48CF-8E24-075DF5B181B9}"/>
               </a:ext>
             </a:extLst>
           </p:cNvPr>
@@ -10021,310 +10285,6 @@
           <a:bodyPr/>
           <a:lstStyle/>
           <a:p>
-            <a:pPr/>
-            <a:r>
-              <a:t>The straightforward scorer: shift each antenna's signal to align with a candidate angle, then sum - a true arrival from that angle adds up in phase (delay-and-sum beamforming)</a:t>
-            </a:r>
-            <a:endParaRPr dirty="0"/>
-          </a:p>
-          <a:p>
-            <a:pPr/>
-            <a:r>
-              <a:t>Sweeping this listening beam across all angles gives the spatial spectrum - like turning an ear toward each direction</a:t>
-            </a:r>
-          </a:p>
-          <a:p>
-            <a:pPr/>
-            <a:r>
-              <a:t>The beam's width is set by array size: with only 2-4 antennas it is roughly 60 degrees wide</a:t>
-            </a:r>
-          </a:p>
-          <a:p>
-            <a:pPr/>
-            <a:r>
-              <a:t>Indoor paths arrive just 10-20 degrees apart, so they merge into one blob inside the wide beam</a:t>
-            </a:r>
-          </a:p>
-          <a:p>
-            <a:pPr/>
-            <a:r>
-              <a:t>More antennas would sharpen the beam - but a commodity AP's antenna count is fixed</a:t>
-            </a:r>
-          </a:p>
-        </p:txBody>
-      </p:sp>
-      <p:sp>
-        <p:nvSpPr>
-          <p:cNvPr id="4" name="投影片編號版面配置區 3">
-            <a:extLst>
-              <a:ext uri="{FF2B5EF4-FFF2-40B4-BE49-F238E27FC236}">
-                <a16:creationId xmlns:a16="http://schemas.microsoft.com/office/drawing/2014/main" id="{C2FCD405-600C-462A-BF29-DAFF79456778}"/>
-              </a:ext>
-            </a:extLst>
-          </p:cNvPr>
-          <p:cNvSpPr>
-            <a:spLocks noGrp="1"/>
-          </p:cNvSpPr>
-          <p:nvPr>
-            <p:ph type="sldNum" idx="10"/>
-          </p:nvPr>
-        </p:nvSpPr>
-        <p:spPr/>
-        <p:txBody>
-          <a:bodyPr/>
-          <a:lstStyle/>
-          <a:p>
-            <a:pPr>
-              <a:buNone/>
-            </a:pPr>
-            <a:fld id="{327921A4-25C4-3DB4-06B1-32693CEE2241}" type="slidenum">
-              <a:rPr sz="1400">
-                <a:latin typeface="Times New Roman"/>
-                <a:ea typeface="Times New Roman"/>
-                <a:cs typeface="Times New Roman"/>
-              </a:rPr>
-              <a:t>11</a:t>
-            </a:fld>
-            <a:endParaRPr sz="1400">
-              <a:latin typeface="Times New Roman"/>
-              <a:ea typeface="Times New Roman"/>
-              <a:cs typeface="Times New Roman"/>
-            </a:endParaRPr>
-          </a:p>
-        </p:txBody>
-      </p:sp>
-    </p:spTree>
-    <p:extLst>
-      <p:ext uri="{BB962C8B-B14F-4D97-AF65-F5344CB8AC3E}">
-        <p14:creationId xmlns:p14="http://schemas.microsoft.com/office/powerpoint/2010/main" val="3499234266"/>
-      </p:ext>
-    </p:extLst>
-  </p:cSld>
-  <p:clrMapOvr>
-    <a:masterClrMapping/>
-  </p:clrMapOvr>
-</p:sld>
-</file>
-
-<file path=ppt/slides/slide13.xml><?xml version="1.0" encoding="utf-8"?>
-<p:sld xmlns:a="http://schemas.openxmlformats.org/drawingml/2006/main" xmlns:r="http://schemas.openxmlformats.org/officeDocument/2006/relationships" xmlns:p="http://schemas.openxmlformats.org/presentationml/2006/main">
-  <p:cSld>
-    <p:spTree>
-      <p:nvGrpSpPr>
-        <p:cNvPr id="1" name=""/>
-        <p:cNvGrpSpPr/>
-        <p:nvPr/>
-      </p:nvGrpSpPr>
-      <p:grpSpPr>
-        <a:xfrm>
-          <a:off x="0" y="0"/>
-          <a:ext cx="0" cy="0"/>
-          <a:chOff x="0" y="0"/>
-          <a:chExt cx="0" cy="0"/>
-        </a:xfrm>
-      </p:grpSpPr>
-      <p:sp>
-        <p:nvSpPr>
-          <p:cNvPr id="2" name="標題 1">
-            <a:extLst>
-              <a:ext uri="{FF2B5EF4-FFF2-40B4-BE49-F238E27FC236}">
-                <a16:creationId xmlns:a16="http://schemas.microsoft.com/office/drawing/2014/main" id="{27A3B284-1CEC-47E9-98B8-BA58ABCB5210}"/>
-              </a:ext>
-            </a:extLst>
-          </p:cNvPr>
-          <p:cNvSpPr>
-            <a:spLocks noGrp="1"/>
-          </p:cNvSpPr>
-          <p:nvPr>
-            <p:ph type="title"/>
-          </p:nvPr>
-        </p:nvSpPr>
-        <p:spPr/>
-        <p:txBody>
-          <a:bodyPr/>
-          <a:lstStyle/>
-          <a:p>
-            <a:r>
-              <a:rPr lang="en-US" altLang="zh-TW" dirty="0"/>
-              <a:t>Why We Use MUSIC</a:t>
-            </a:r>
-            <a:endParaRPr b="1" dirty="0"/>
-          </a:p>
-        </p:txBody>
-      </p:sp>
-      <p:sp>
-        <p:nvSpPr>
-          <p:cNvPr id="3" name="內容版面配置區 2">
-            <a:extLst>
-              <a:ext uri="{FF2B5EF4-FFF2-40B4-BE49-F238E27FC236}">
-                <a16:creationId xmlns:a16="http://schemas.microsoft.com/office/drawing/2014/main" id="{85EB7868-0B10-4ADE-BF08-3CE42A258785}"/>
-              </a:ext>
-            </a:extLst>
-          </p:cNvPr>
-          <p:cNvSpPr>
-            <a:spLocks noGrp="1"/>
-          </p:cNvSpPr>
-          <p:nvPr>
-            <p:ph idx="1"/>
-          </p:nvPr>
-        </p:nvSpPr>
-        <p:spPr/>
-        <p:txBody>
-          <a:bodyPr/>
-          <a:lstStyle/>
-          <a:p>
-            <a:pPr/>
-            <a:r>
-              <a:t>MUSIC skips the beam entirely: it exploits the statistical structure of the received signal to test each angle directly, so resolution is not capped by antenna count</a:t>
-            </a:r>
-            <a:endParaRPr dirty="0"/>
-          </a:p>
-          <a:p>
-            <a:pPr/>
-            <a:r>
-              <a:t>Faster alternatives fit poorly: ESPRIT's algebraic shortcut exists only for strictly regular arrays and degrades under heavy multipath; exhaustive-search ML is accurate but computationally infeasible</a:t>
-            </a:r>
-          </a:p>
-          <a:p>
-            <a:pPr/>
-            <a:r>
-              <a:t>MUSIC works with any known antenna layout and stays robust in multipath; its heavier computation is affordable since localization does not need fast updates</a:t>
-            </a:r>
-          </a:p>
-          <a:p>
-            <a:pPr/>
-            <a:r>
-              <a:t>Proven on our hardware class: SpotFi reaches ~40 cm median accuracy with 3 antennas using MUSIC</a:t>
-            </a:r>
-          </a:p>
-          <a:p>
-            <a:pPr/>
-            <a:r>
-              <a:t>We therefore adopt MUSIC for AP-side AoA estimation</a:t>
-            </a:r>
-          </a:p>
-        </p:txBody>
-      </p:sp>
-      <p:sp>
-        <p:nvSpPr>
-          <p:cNvPr id="4" name="投影片編號版面配置區 3">
-            <a:extLst>
-              <a:ext uri="{FF2B5EF4-FFF2-40B4-BE49-F238E27FC236}">
-                <a16:creationId xmlns:a16="http://schemas.microsoft.com/office/drawing/2014/main" id="{C2FCD405-600C-462A-BF29-DAFF79456778}"/>
-              </a:ext>
-            </a:extLst>
-          </p:cNvPr>
-          <p:cNvSpPr>
-            <a:spLocks noGrp="1"/>
-          </p:cNvSpPr>
-          <p:nvPr>
-            <p:ph type="sldNum" idx="10"/>
-          </p:nvPr>
-        </p:nvSpPr>
-        <p:spPr/>
-        <p:txBody>
-          <a:bodyPr/>
-          <a:lstStyle/>
-          <a:p>
-            <a:pPr>
-              <a:buNone/>
-            </a:pPr>
-            <a:fld id="{327921A4-25C4-3DB4-06B1-32693CEE2241}" type="slidenum">
-              <a:rPr sz="1400">
-                <a:latin typeface="Times New Roman"/>
-                <a:ea typeface="Times New Roman"/>
-                <a:cs typeface="Times New Roman"/>
-              </a:rPr>
-              <a:t>11</a:t>
-            </a:fld>
-            <a:endParaRPr sz="1400">
-              <a:latin typeface="Times New Roman"/>
-              <a:ea typeface="Times New Roman"/>
-              <a:cs typeface="Times New Roman"/>
-            </a:endParaRPr>
-          </a:p>
-        </p:txBody>
-      </p:sp>
-    </p:spTree>
-    <p:extLst>
-      <p:ext uri="{BB962C8B-B14F-4D97-AF65-F5344CB8AC3E}">
-        <p14:creationId xmlns:p14="http://schemas.microsoft.com/office/powerpoint/2010/main" val="3499234266"/>
-      </p:ext>
-    </p:extLst>
-  </p:cSld>
-  <p:clrMapOvr>
-    <a:masterClrMapping/>
-  </p:clrMapOvr>
-</p:sld>
-</file>
-
-<file path=ppt/slides/slide14.xml><?xml version="1.0" encoding="utf-8"?>
-<p:sld xmlns:a="http://schemas.openxmlformats.org/drawingml/2006/main" xmlns:r="http://schemas.openxmlformats.org/officeDocument/2006/relationships" xmlns:p="http://schemas.openxmlformats.org/presentationml/2006/main">
-  <p:cSld>
-    <p:spTree>
-      <p:nvGrpSpPr>
-        <p:cNvPr id="1" name=""/>
-        <p:cNvGrpSpPr/>
-        <p:nvPr/>
-      </p:nvGrpSpPr>
-      <p:grpSpPr>
-        <a:xfrm>
-          <a:off x="0" y="0"/>
-          <a:ext cx="0" cy="0"/>
-          <a:chOff x="0" y="0"/>
-          <a:chExt cx="0" cy="0"/>
-        </a:xfrm>
-      </p:grpSpPr>
-      <p:sp>
-        <p:nvSpPr>
-          <p:cNvPr id="2" name="標題 1">
-            <a:extLst>
-              <a:ext uri="{FF2B5EF4-FFF2-40B4-BE49-F238E27FC236}">
-                <a16:creationId xmlns:a16="http://schemas.microsoft.com/office/drawing/2014/main" id="{155386B2-4D86-418A-841B-0E5321F04EE6}"/>
-              </a:ext>
-            </a:extLst>
-          </p:cNvPr>
-          <p:cNvSpPr>
-            <a:spLocks noGrp="1"/>
-          </p:cNvSpPr>
-          <p:nvPr>
-            <p:ph type="title"/>
-          </p:nvPr>
-        </p:nvSpPr>
-        <p:spPr/>
-        <p:txBody>
-          <a:bodyPr/>
-          <a:lstStyle/>
-          <a:p>
-            <a:r>
-              <a:rPr lang="en-US" altLang="zh-TW" dirty="0"/>
-              <a:t>Steering Vector Encodes Angle-Dependent Phase</a:t>
-            </a:r>
-            <a:endParaRPr lang="zh-TW" altLang="en-US" dirty="0"/>
-          </a:p>
-        </p:txBody>
-      </p:sp>
-      <p:sp>
-        <p:nvSpPr>
-          <p:cNvPr id="3" name="內容版面配置區 2">
-            <a:extLst>
-              <a:ext uri="{FF2B5EF4-FFF2-40B4-BE49-F238E27FC236}">
-                <a16:creationId xmlns:a16="http://schemas.microsoft.com/office/drawing/2014/main" id="{D6A93578-5499-48CF-8E24-075DF5B181B9}"/>
-              </a:ext>
-            </a:extLst>
-          </p:cNvPr>
-          <p:cNvSpPr>
-            <a:spLocks noGrp="1"/>
-          </p:cNvSpPr>
-          <p:nvPr>
-            <p:ph idx="1"/>
-          </p:nvPr>
-        </p:nvSpPr>
-        <p:spPr/>
-        <p:txBody>
-          <a:bodyPr/>
-          <a:lstStyle/>
-          <a:p>
             <a:r>
               <a:rPr lang="en-US" altLang="zh-TW" dirty="0"/>
               <a:t>Phase pattern across the antenna array when a signal arrives from angle θ</a:t>
@@ -10342,7 +10302,6 @@
             <a:endParaRPr lang="zh-TW" altLang="en-US" dirty="0"/>
           </a:p>
           <a:p>
-            <a:pPr/>
             <a:r>
               <a:t>The simplest way to use this pattern: align each antenna's signal and sum</a:t>
             </a:r>
@@ -11040,6 +10999,312 @@
 </p:sld>
 </file>
 
+<file path=ppt/slides/slide13.xml><?xml version="1.0" encoding="utf-8"?>
+<p:sld xmlns:a="http://schemas.openxmlformats.org/drawingml/2006/main" xmlns:r="http://schemas.openxmlformats.org/officeDocument/2006/relationships" xmlns:p="http://schemas.openxmlformats.org/presentationml/2006/main">
+  <p:cSld>
+    <p:spTree>
+      <p:nvGrpSpPr>
+        <p:cNvPr id="1" name=""/>
+        <p:cNvGrpSpPr/>
+        <p:nvPr/>
+      </p:nvGrpSpPr>
+      <p:grpSpPr>
+        <a:xfrm>
+          <a:off x="0" y="0"/>
+          <a:ext cx="0" cy="0"/>
+          <a:chOff x="0" y="0"/>
+          <a:chExt cx="0" cy="0"/>
+        </a:xfrm>
+      </p:grpSpPr>
+      <p:sp>
+        <p:nvSpPr>
+          <p:cNvPr id="2" name="標題 1">
+            <a:extLst>
+              <a:ext uri="{FF2B5EF4-FFF2-40B4-BE49-F238E27FC236}">
+                <a16:creationId xmlns:a16="http://schemas.microsoft.com/office/drawing/2014/main" id="{27A3B284-1CEC-47E9-98B8-BA58ABCB5210}"/>
+              </a:ext>
+            </a:extLst>
+          </p:cNvPr>
+          <p:cNvSpPr>
+            <a:spLocks noGrp="1"/>
+          </p:cNvSpPr>
+          <p:nvPr>
+            <p:ph type="title"/>
+          </p:nvPr>
+        </p:nvSpPr>
+        <p:spPr/>
+        <p:txBody>
+          <a:bodyPr/>
+          <a:lstStyle/>
+          <a:p>
+            <a:r>
+              <a:rPr lang="en-US" altLang="zh-TW" dirty="0"/>
+              <a:t>Classic Beamforming Hits a Resolution Wall</a:t>
+            </a:r>
+            <a:endParaRPr b="1" dirty="0"/>
+          </a:p>
+        </p:txBody>
+      </p:sp>
+      <p:sp>
+        <p:nvSpPr>
+          <p:cNvPr id="3" name="內容版面配置區 2">
+            <a:extLst>
+              <a:ext uri="{FF2B5EF4-FFF2-40B4-BE49-F238E27FC236}">
+                <a16:creationId xmlns:a16="http://schemas.microsoft.com/office/drawing/2014/main" id="{85EB7868-0B10-4ADE-BF08-3CE42A258785}"/>
+              </a:ext>
+            </a:extLst>
+          </p:cNvPr>
+          <p:cNvSpPr>
+            <a:spLocks noGrp="1"/>
+          </p:cNvSpPr>
+          <p:nvPr>
+            <p:ph idx="1"/>
+          </p:nvPr>
+        </p:nvSpPr>
+        <p:spPr/>
+        <p:txBody>
+          <a:bodyPr/>
+          <a:lstStyle/>
+          <a:p>
+            <a:r>
+              <a:t>The straightforward scorer: shift each antenna's signal to align with a candidate angle, then sum - a true arrival from that angle adds up in phase (delay-and-sum beamforming)</a:t>
+            </a:r>
+            <a:endParaRPr dirty="0"/>
+          </a:p>
+          <a:p>
+            <a:r>
+              <a:t>Sweeping this listening beam across all angles gives the spatial spectrum - like turning an ear toward each direction</a:t>
+            </a:r>
+          </a:p>
+          <a:p>
+            <a:r>
+              <a:t>The beam's width is set by array size: with only 2-4 antennas it is roughly 60 degrees wide</a:t>
+            </a:r>
+          </a:p>
+          <a:p>
+            <a:r>
+              <a:t>Indoor paths arrive just 10-20 degrees apart, so they merge into one blob inside the wide beam</a:t>
+            </a:r>
+          </a:p>
+          <a:p>
+            <a:r>
+              <a:t>More antennas would sharpen the beam - but a commodity AP's antenna count is fixed</a:t>
+            </a:r>
+          </a:p>
+        </p:txBody>
+      </p:sp>
+      <p:sp>
+        <p:nvSpPr>
+          <p:cNvPr id="4" name="投影片編號版面配置區 3">
+            <a:extLst>
+              <a:ext uri="{FF2B5EF4-FFF2-40B4-BE49-F238E27FC236}">
+                <a16:creationId xmlns:a16="http://schemas.microsoft.com/office/drawing/2014/main" id="{C2FCD405-600C-462A-BF29-DAFF79456778}"/>
+              </a:ext>
+            </a:extLst>
+          </p:cNvPr>
+          <p:cNvSpPr>
+            <a:spLocks noGrp="1"/>
+          </p:cNvSpPr>
+          <p:nvPr>
+            <p:ph type="sldNum" idx="10"/>
+          </p:nvPr>
+        </p:nvSpPr>
+        <p:spPr/>
+        <p:txBody>
+          <a:bodyPr/>
+          <a:lstStyle/>
+          <a:p>
+            <a:pPr>
+              <a:buNone/>
+            </a:pPr>
+            <a:fld id="{327921A4-25C4-3DB4-06B1-32693CEE2241}" type="slidenum">
+              <a:rPr sz="1400">
+                <a:latin typeface="Times New Roman"/>
+                <a:ea typeface="Times New Roman"/>
+                <a:cs typeface="Times New Roman"/>
+              </a:rPr>
+              <a:t>13</a:t>
+            </a:fld>
+            <a:endParaRPr sz="1400">
+              <a:latin typeface="Times New Roman"/>
+              <a:ea typeface="Times New Roman"/>
+              <a:cs typeface="Times New Roman"/>
+            </a:endParaRPr>
+          </a:p>
+        </p:txBody>
+      </p:sp>
+    </p:spTree>
+    <p:extLst>
+      <p:ext uri="{BB962C8B-B14F-4D97-AF65-F5344CB8AC3E}">
+        <p14:creationId xmlns:p14="http://schemas.microsoft.com/office/powerpoint/2010/main" val="3499234266"/>
+      </p:ext>
+    </p:extLst>
+  </p:cSld>
+  <p:clrMapOvr>
+    <a:masterClrMapping/>
+  </p:clrMapOvr>
+</p:sld>
+</file>
+
+<file path=ppt/slides/slide14.xml><?xml version="1.0" encoding="utf-8"?>
+<p:sld xmlns:a="http://schemas.openxmlformats.org/drawingml/2006/main" xmlns:r="http://schemas.openxmlformats.org/officeDocument/2006/relationships" xmlns:p="http://schemas.openxmlformats.org/presentationml/2006/main">
+  <p:cSld>
+    <p:spTree>
+      <p:nvGrpSpPr>
+        <p:cNvPr id="1" name=""/>
+        <p:cNvGrpSpPr/>
+        <p:nvPr/>
+      </p:nvGrpSpPr>
+      <p:grpSpPr>
+        <a:xfrm>
+          <a:off x="0" y="0"/>
+          <a:ext cx="0" cy="0"/>
+          <a:chOff x="0" y="0"/>
+          <a:chExt cx="0" cy="0"/>
+        </a:xfrm>
+      </p:grpSpPr>
+      <p:sp>
+        <p:nvSpPr>
+          <p:cNvPr id="2" name="標題 1">
+            <a:extLst>
+              <a:ext uri="{FF2B5EF4-FFF2-40B4-BE49-F238E27FC236}">
+                <a16:creationId xmlns:a16="http://schemas.microsoft.com/office/drawing/2014/main" id="{27A3B284-1CEC-47E9-98B8-BA58ABCB5210}"/>
+              </a:ext>
+            </a:extLst>
+          </p:cNvPr>
+          <p:cNvSpPr>
+            <a:spLocks noGrp="1"/>
+          </p:cNvSpPr>
+          <p:nvPr>
+            <p:ph type="title"/>
+          </p:nvPr>
+        </p:nvSpPr>
+        <p:spPr/>
+        <p:txBody>
+          <a:bodyPr/>
+          <a:lstStyle/>
+          <a:p>
+            <a:r>
+              <a:rPr lang="en-US" altLang="zh-TW" dirty="0"/>
+              <a:t>Why We Use MUSIC</a:t>
+            </a:r>
+            <a:endParaRPr b="1" dirty="0"/>
+          </a:p>
+        </p:txBody>
+      </p:sp>
+      <p:sp>
+        <p:nvSpPr>
+          <p:cNvPr id="3" name="內容版面配置區 2">
+            <a:extLst>
+              <a:ext uri="{FF2B5EF4-FFF2-40B4-BE49-F238E27FC236}">
+                <a16:creationId xmlns:a16="http://schemas.microsoft.com/office/drawing/2014/main" id="{85EB7868-0B10-4ADE-BF08-3CE42A258785}"/>
+              </a:ext>
+            </a:extLst>
+          </p:cNvPr>
+          <p:cNvSpPr>
+            <a:spLocks noGrp="1"/>
+          </p:cNvSpPr>
+          <p:nvPr>
+            <p:ph idx="1"/>
+          </p:nvPr>
+        </p:nvSpPr>
+        <p:spPr/>
+        <p:txBody>
+          <a:bodyPr/>
+          <a:lstStyle/>
+          <a:p>
+            <a:r>
+              <a:rPr dirty="0"/>
+              <a:t>MUSIC skips the beam entirely: it exploits the statistical structure of the received signal to test each angle directly, so resolution is not capped by antenna count</a:t>
+            </a:r>
+          </a:p>
+          <a:p>
+            <a:r>
+              <a:rPr dirty="0"/>
+              <a:t>Faster alternatives fit poorly: ESPRIT's algebraic shortcut exists only for strictly regular arrays and degrades under heavy multipath; exhaustive-search ML is accurate but computationally infeasible</a:t>
+            </a:r>
+          </a:p>
+          <a:p>
+            <a:r>
+              <a:rPr dirty="0"/>
+              <a:t>MUSIC works with any known antenna layout and stays robust in multipath; its heavier computation is affordable since localization does not need fast updates</a:t>
+            </a:r>
+          </a:p>
+          <a:p>
+            <a:r>
+              <a:rPr dirty="0"/>
+              <a:t>Proven on our hardware class: </a:t>
+            </a:r>
+            <a:r>
+              <a:rPr dirty="0" err="1"/>
+              <a:t>SpotFi</a:t>
+            </a:r>
+            <a:r>
+              <a:rPr dirty="0"/>
+              <a:t> reaches ~40 cm median accuracy with 3 antennas using MUSIC</a:t>
+            </a:r>
+          </a:p>
+          <a:p>
+            <a:r>
+              <a:rPr dirty="0"/>
+              <a:t>We therefore adopt MUSIC for AP-side AoA estimation</a:t>
+            </a:r>
+          </a:p>
+        </p:txBody>
+      </p:sp>
+      <p:sp>
+        <p:nvSpPr>
+          <p:cNvPr id="4" name="投影片編號版面配置區 3">
+            <a:extLst>
+              <a:ext uri="{FF2B5EF4-FFF2-40B4-BE49-F238E27FC236}">
+                <a16:creationId xmlns:a16="http://schemas.microsoft.com/office/drawing/2014/main" id="{C2FCD405-600C-462A-BF29-DAFF79456778}"/>
+              </a:ext>
+            </a:extLst>
+          </p:cNvPr>
+          <p:cNvSpPr>
+            <a:spLocks noGrp="1"/>
+          </p:cNvSpPr>
+          <p:nvPr>
+            <p:ph type="sldNum" idx="10"/>
+          </p:nvPr>
+        </p:nvSpPr>
+        <p:spPr/>
+        <p:txBody>
+          <a:bodyPr/>
+          <a:lstStyle/>
+          <a:p>
+            <a:pPr>
+              <a:buNone/>
+            </a:pPr>
+            <a:fld id="{327921A4-25C4-3DB4-06B1-32693CEE2241}" type="slidenum">
+              <a:rPr sz="1400">
+                <a:latin typeface="Times New Roman"/>
+                <a:ea typeface="Times New Roman"/>
+                <a:cs typeface="Times New Roman"/>
+              </a:rPr>
+              <a:t>14</a:t>
+            </a:fld>
+            <a:endParaRPr sz="1400">
+              <a:latin typeface="Times New Roman"/>
+              <a:ea typeface="Times New Roman"/>
+              <a:cs typeface="Times New Roman"/>
+            </a:endParaRPr>
+          </a:p>
+        </p:txBody>
+      </p:sp>
+    </p:spTree>
+    <p:extLst>
+      <p:ext uri="{BB962C8B-B14F-4D97-AF65-F5344CB8AC3E}">
+        <p14:creationId xmlns:p14="http://schemas.microsoft.com/office/powerpoint/2010/main" val="3499234266"/>
+      </p:ext>
+    </p:extLst>
+  </p:cSld>
+  <p:clrMapOvr>
+    <a:masterClrMapping/>
+  </p:clrMapOvr>
+</p:sld>
+</file>
+
 <file path=ppt/slides/slide15.xml><?xml version="1.0" encoding="utf-8"?>
 <p:sld xmlns:a="http://schemas.openxmlformats.org/drawingml/2006/main" xmlns:r="http://schemas.openxmlformats.org/officeDocument/2006/relationships" xmlns:p="http://schemas.openxmlformats.org/presentationml/2006/main">
   <p:cSld>
@@ -11169,7 +11434,7 @@
                 <a:ea typeface="Times New Roman"/>
                 <a:cs typeface="Times New Roman"/>
               </a:rPr>
-              <a:t>13</a:t>
+              <a:t>15</a:t>
             </a:fld>
             <a:endParaRPr sz="1400">
               <a:latin typeface="Times New Roman"/>
@@ -11301,7 +11566,7 @@
                 <a:ea typeface="Times New Roman"/>
                 <a:cs typeface="Times New Roman"/>
               </a:rPr>
-              <a:t>15</a:t>
+              <a:t>16</a:t>
             </a:fld>
             <a:endParaRPr sz="1400">
               <a:latin typeface="Times New Roman"/>
@@ -11371,7 +11636,7 @@
                 <a:ea typeface="Times New Roman"/>
                 <a:cs typeface="Times New Roman"/>
               </a:rPr>
-              <a:t>16</a:t>
+              <a:t>17</a:t>
             </a:fld>
             <a:endParaRPr sz="1400">
               <a:latin typeface="Times New Roman"/>
@@ -11564,11 +11829,13 @@
           <a:lstStyle/>
           <a:p>
             <a:r>
+              <a:rPr dirty="0"/>
               <a:t>The AP uses AoA and link observations to decide when RTS/CTS overhead is worthwhile.</a:t>
             </a:r>
           </a:p>
           <a:p>
             <a:r>
+              <a:rPr dirty="0"/>
               <a:t>The hidden-node risk score becomes the decision variable for RTS threshold control.</a:t>
             </a:r>
           </a:p>
@@ -11604,7 +11871,7 @@
                 <a:ea typeface="Times New Roman"/>
                 <a:cs typeface="Times New Roman"/>
               </a:rPr>
-              <a:t>17</a:t>
+              <a:t>18</a:t>
             </a:fld>
             <a:endParaRPr sz="1400">
               <a:latin typeface="Times New Roman"/>
@@ -11666,7 +11933,7 @@
           <a:lstStyle/>
           <a:p>
             <a:r>
-              <a:rPr b="1"/>
+              <a:rPr b="1" dirty="0"/>
               <a:t>AoA and Link Features Capture Hidden-Node Risk</a:t>
             </a:r>
           </a:p>
@@ -11694,11 +11961,13 @@
           <a:lstStyle/>
           <a:p>
             <a:r>
+              <a:rPr dirty="0"/>
               <a:t>AoA estimates from AP-side multi-antenna CSI provide the main spatial feature for hidden-node risk.</a:t>
             </a:r>
           </a:p>
           <a:p>
             <a:r>
+              <a:rPr dirty="0"/>
               <a:t>The score combines AoA separation with retries, RSSI, MCS, and traffic activity to reflect geometry and collision symptoms.</a:t>
             </a:r>
           </a:p>
@@ -11734,7 +12003,7 @@
                 <a:ea typeface="Times New Roman"/>
                 <a:cs typeface="Times New Roman"/>
               </a:rPr>
-              <a:t>18</a:t>
+              <a:t>19</a:t>
             </a:fld>
             <a:endParaRPr sz="1400">
               <a:latin typeface="Times New Roman"/>
@@ -11977,11 +12246,13 @@
           <a:lstStyle/>
           <a:p>
             <a:r>
+              <a:rPr dirty="0"/>
               <a:t>Lower the threshold when hidden-node risk is high; restore or raise it when risk is low.</a:t>
             </a:r>
           </a:p>
           <a:p>
             <a:r>
+              <a:rPr dirty="0"/>
               <a:t>Smoothing and hysteresis prevent oscillation under noisy AoA or retry measurements.</a:t>
             </a:r>
           </a:p>
@@ -12017,7 +12288,7 @@
                 <a:ea typeface="Times New Roman"/>
                 <a:cs typeface="Times New Roman"/>
               </a:rPr>
-              <a:t>19</a:t>
+              <a:t>20</a:t>
             </a:fld>
             <a:endParaRPr sz="1400">
               <a:latin typeface="Times New Roman"/>
@@ -12087,7 +12358,7 @@
                 <a:ea typeface="Times New Roman"/>
                 <a:cs typeface="Times New Roman"/>
               </a:rPr>
-              <a:t>20</a:t>
+              <a:t>21</a:t>
             </a:fld>
             <a:endParaRPr sz="1400">
               <a:latin typeface="Times New Roman"/>
@@ -12335,7 +12606,7 @@
                 <a:ea typeface="Times New Roman"/>
                 <a:cs typeface="Times New Roman"/>
               </a:rPr>
-              <a:t>21</a:t>
+              <a:t>22</a:t>
             </a:fld>
             <a:endParaRPr sz="1400">
               <a:latin typeface="Times New Roman"/>
@@ -12460,7 +12731,7 @@
                 <a:ea typeface="Times New Roman"/>
                 <a:cs typeface="Times New Roman"/>
               </a:rPr>
-              <a:t>22</a:t>
+              <a:t>23</a:t>
             </a:fld>
             <a:endParaRPr sz="1400">
               <a:latin typeface="Times New Roman"/>
@@ -12530,7 +12801,7 @@
                 <a:ea typeface="Times New Roman"/>
                 <a:cs typeface="Times New Roman"/>
               </a:rPr>
-              <a:t>23</a:t>
+              <a:t>24</a:t>
             </a:fld>
             <a:endParaRPr sz="1400">
               <a:latin typeface="Times New Roman"/>
@@ -12657,6 +12928,968 @@
     <p:extLst>
       <p:ext uri="{BB962C8B-B14F-4D97-AF65-F5344CB8AC3E}">
         <p14:creationId xmlns:p14="http://schemas.microsoft.com/office/powerpoint/2010/main" val="756668717"/>
+      </p:ext>
+    </p:extLst>
+  </p:cSld>
+  <p:clrMapOvr>
+    <a:masterClrMapping/>
+  </p:clrMapOvr>
+</p:sld>
+</file>
+
+<file path=ppt/slides/slide25.xml><?xml version="1.0" encoding="utf-8"?>
+<p:sld xmlns:a="http://schemas.openxmlformats.org/drawingml/2006/main" xmlns:r="http://schemas.openxmlformats.org/officeDocument/2006/relationships" xmlns:p="http://schemas.openxmlformats.org/presentationml/2006/main">
+  <p:cSld>
+    <p:spTree>
+      <p:nvGrpSpPr>
+        <p:cNvPr id="1" name=""/>
+        <p:cNvGrpSpPr/>
+        <p:nvPr/>
+      </p:nvGrpSpPr>
+      <p:grpSpPr>
+        <a:xfrm>
+          <a:off x="0" y="0"/>
+          <a:ext cx="0" cy="0"/>
+          <a:chOff x="0" y="0"/>
+          <a:chExt cx="0" cy="0"/>
+        </a:xfrm>
+      </p:grpSpPr>
+      <p:sp>
+        <p:nvSpPr>
+          <p:cNvPr id="2" name="標題 1">
+            <a:extLst>
+              <a:ext uri="{FF2B5EF4-FFF2-40B4-BE49-F238E27FC236}">
+                <a16:creationId xmlns:a16="http://schemas.microsoft.com/office/drawing/2014/main" id="{CA94F076-2DF4-9E29-862A-AB256C8C3AB1}"/>
+              </a:ext>
+            </a:extLst>
+          </p:cNvPr>
+          <p:cNvSpPr>
+            <a:spLocks noGrp="1"/>
+          </p:cNvSpPr>
+          <p:nvPr>
+            <p:ph type="title"/>
+          </p:nvPr>
+        </p:nvSpPr>
+        <p:spPr/>
+        <p:txBody>
+          <a:bodyPr/>
+          <a:lstStyle/>
+          <a:p>
+            <a:r>
+              <a:rPr lang="en-US" altLang="zh-TW" dirty="0"/>
+              <a:t>Appendix</a:t>
+            </a:r>
+            <a:endParaRPr lang="zh-TW" altLang="en-US" dirty="0"/>
+          </a:p>
+        </p:txBody>
+      </p:sp>
+      <p:sp>
+        <p:nvSpPr>
+          <p:cNvPr id="3" name="內容版面配置區 2">
+            <a:extLst>
+              <a:ext uri="{FF2B5EF4-FFF2-40B4-BE49-F238E27FC236}">
+                <a16:creationId xmlns:a16="http://schemas.microsoft.com/office/drawing/2014/main" id="{ACAAB997-52DC-E930-769C-64DBDAF0E699}"/>
+              </a:ext>
+            </a:extLst>
+          </p:cNvPr>
+          <p:cNvSpPr>
+            <a:spLocks noGrp="1"/>
+          </p:cNvSpPr>
+          <p:nvPr>
+            <p:ph idx="1"/>
+          </p:nvPr>
+        </p:nvSpPr>
+        <p:spPr/>
+        <p:txBody>
+          <a:bodyPr/>
+          <a:lstStyle/>
+          <a:p>
+            <a:endParaRPr lang="zh-TW" altLang="en-US"/>
+          </a:p>
+        </p:txBody>
+      </p:sp>
+      <p:sp>
+        <p:nvSpPr>
+          <p:cNvPr id="4" name="投影片編號版面配置區 3">
+            <a:extLst>
+              <a:ext uri="{FF2B5EF4-FFF2-40B4-BE49-F238E27FC236}">
+                <a16:creationId xmlns:a16="http://schemas.microsoft.com/office/drawing/2014/main" id="{6C2EBAC9-5BB1-9D5C-FA3C-1E85B99DD17F}"/>
+              </a:ext>
+            </a:extLst>
+          </p:cNvPr>
+          <p:cNvSpPr>
+            <a:spLocks noGrp="1"/>
+          </p:cNvSpPr>
+          <p:nvPr>
+            <p:ph type="sldNum" sz="quarter" idx="10"/>
+          </p:nvPr>
+        </p:nvSpPr>
+        <p:spPr/>
+        <p:txBody>
+          <a:bodyPr/>
+          <a:lstStyle/>
+          <a:p>
+            <a:pPr>
+              <a:defRPr/>
+            </a:pPr>
+            <a:fld id="{DBC8A1ED-4F98-4D8C-81F6-271243F7D6B0}" type="slidenum">
+              <a:rPr lang="en-US" altLang="zh-TW" sz="1400" smtClean="0">
+                <a:latin typeface="Times New Roman" pitchFamily="18" charset="0"/>
+              </a:rPr>
+              <a:pPr>
+                <a:defRPr/>
+              </a:pPr>
+              <a:t>25</a:t>
+            </a:fld>
+            <a:endParaRPr lang="en-US" altLang="zh-TW" sz="1400">
+              <a:latin typeface="Times New Roman" pitchFamily="18" charset="0"/>
+            </a:endParaRPr>
+          </a:p>
+        </p:txBody>
+      </p:sp>
+    </p:spTree>
+    <p:extLst>
+      <p:ext uri="{BB962C8B-B14F-4D97-AF65-F5344CB8AC3E}">
+        <p14:creationId xmlns:p14="http://schemas.microsoft.com/office/powerpoint/2010/main" val="1929645611"/>
+      </p:ext>
+    </p:extLst>
+  </p:cSld>
+  <p:clrMapOvr>
+    <a:masterClrMapping/>
+  </p:clrMapOvr>
+</p:sld>
+</file>
+
+<file path=ppt/slides/slide26.xml><?xml version="1.0" encoding="utf-8"?>
+<p:sld xmlns:a="http://schemas.openxmlformats.org/drawingml/2006/main" xmlns:r="http://schemas.openxmlformats.org/officeDocument/2006/relationships" xmlns:p="http://schemas.openxmlformats.org/presentationml/2006/main" show="0">
+  <p:cSld>
+    <p:spTree>
+      <p:nvGrpSpPr>
+        <p:cNvPr id="1" name="">
+          <a:extLst>
+            <a:ext uri="{FF2B5EF4-FFF2-40B4-BE49-F238E27FC236}">
+              <a16:creationId xmlns:a16="http://schemas.microsoft.com/office/drawing/2014/main" id="{BAFBF0E1-39CB-5C7F-5C2C-3FAEEF8D82E9}"/>
+            </a:ext>
+          </a:extLst>
+        </p:cNvPr>
+        <p:cNvGrpSpPr/>
+        <p:nvPr/>
+      </p:nvGrpSpPr>
+      <p:grpSpPr>
+        <a:xfrm>
+          <a:off x="0" y="0"/>
+          <a:ext cx="0" cy="0"/>
+          <a:chOff x="0" y="0"/>
+          <a:chExt cx="0" cy="0"/>
+        </a:xfrm>
+      </p:grpSpPr>
+      <p:sp>
+        <p:nvSpPr>
+          <p:cNvPr id="2" name="標題 1">
+            <a:extLst>
+              <a:ext uri="{FF2B5EF4-FFF2-40B4-BE49-F238E27FC236}">
+                <a16:creationId xmlns:a16="http://schemas.microsoft.com/office/drawing/2014/main" id="{98E2A0F9-9AD2-8D3B-3924-7807A20D24C7}"/>
+              </a:ext>
+            </a:extLst>
+          </p:cNvPr>
+          <p:cNvSpPr>
+            <a:spLocks noGrp="1"/>
+          </p:cNvSpPr>
+          <p:nvPr>
+            <p:ph type="title"/>
+          </p:nvPr>
+        </p:nvSpPr>
+        <p:spPr/>
+        <p:txBody>
+          <a:bodyPr/>
+          <a:lstStyle/>
+          <a:p>
+            <a:r>
+              <a:rPr lang="en-US" altLang="zh-TW" dirty="0"/>
+              <a:t>RTS/CTS Mitigates Hidden-Node Collisions</a:t>
+            </a:r>
+            <a:endParaRPr dirty="0"/>
+          </a:p>
+        </p:txBody>
+      </p:sp>
+      <p:sp>
+        <p:nvSpPr>
+          <p:cNvPr id="3" name="內容版面配置區 2">
+            <a:extLst>
+              <a:ext uri="{FF2B5EF4-FFF2-40B4-BE49-F238E27FC236}">
+                <a16:creationId xmlns:a16="http://schemas.microsoft.com/office/drawing/2014/main" id="{1F014A24-8912-C2E4-B047-76FA0E7DBD99}"/>
+              </a:ext>
+            </a:extLst>
+          </p:cNvPr>
+          <p:cNvSpPr>
+            <a:spLocks noGrp="1"/>
+          </p:cNvSpPr>
+          <p:nvPr>
+            <p:ph idx="1"/>
+          </p:nvPr>
+        </p:nvSpPr>
+        <p:spPr>
+          <a:ln>
+            <a:noFill/>
+            <a:prstDash val="solid"/>
+          </a:ln>
+        </p:spPr>
+        <p:txBody>
+          <a:bodyPr/>
+          <a:lstStyle/>
+          <a:p>
+            <a:endParaRPr lang="zh-TW" altLang="zh-TW" dirty="0"/>
+          </a:p>
+        </p:txBody>
+      </p:sp>
+      <p:sp>
+        <p:nvSpPr>
+          <p:cNvPr id="4" name="投影片編號版面配置區 3">
+            <a:extLst>
+              <a:ext uri="{FF2B5EF4-FFF2-40B4-BE49-F238E27FC236}">
+                <a16:creationId xmlns:a16="http://schemas.microsoft.com/office/drawing/2014/main" id="{623A8A2A-9895-F6E4-2B85-BF9087209916}"/>
+              </a:ext>
+            </a:extLst>
+          </p:cNvPr>
+          <p:cNvSpPr>
+            <a:spLocks noGrp="1"/>
+          </p:cNvSpPr>
+          <p:nvPr>
+            <p:ph type="sldNum" idx="10"/>
+          </p:nvPr>
+        </p:nvSpPr>
+        <p:spPr/>
+        <p:txBody>
+          <a:bodyPr/>
+          <a:lstStyle/>
+          <a:p>
+            <a:pPr>
+              <a:buNone/>
+            </a:pPr>
+            <a:fld id="{D3D7D1C8-AE23-AA48-DF65-C742588DBE47}" type="slidenum">
+              <a:rPr sz="1400">
+                <a:latin typeface="Times New Roman"/>
+                <a:ea typeface="Times New Roman"/>
+                <a:cs typeface="Times New Roman"/>
+              </a:rPr>
+              <a:t>26</a:t>
+            </a:fld>
+            <a:endParaRPr sz="1400">
+              <a:latin typeface="Times New Roman"/>
+              <a:ea typeface="Times New Roman"/>
+              <a:cs typeface="Times New Roman"/>
+            </a:endParaRPr>
+          </a:p>
+        </p:txBody>
+      </p:sp>
+      <p:pic>
+        <p:nvPicPr>
+          <p:cNvPr id="8" name="圖片 7">
+            <a:extLst>
+              <a:ext uri="{FF2B5EF4-FFF2-40B4-BE49-F238E27FC236}">
+                <a16:creationId xmlns:a16="http://schemas.microsoft.com/office/drawing/2014/main" id="{F66C6B06-146C-8446-740C-954B48AB9D95}"/>
+              </a:ext>
+            </a:extLst>
+          </p:cNvPr>
+          <p:cNvPicPr>
+            <a:picLocks noChangeAspect="1"/>
+          </p:cNvPicPr>
+          <p:nvPr/>
+        </p:nvPicPr>
+        <p:blipFill>
+          <a:blip r:embed="rId3">
+            <a:extLst>
+              <a:ext uri="{28A0092B-C50C-407E-A947-70E740481C1C}">
+                <a14:useLocalDpi xmlns:a14="http://schemas.microsoft.com/office/drawing/2010/main" val="0"/>
+              </a:ext>
+            </a:extLst>
+          </a:blip>
+          <a:stretch>
+            <a:fillRect/>
+          </a:stretch>
+        </p:blipFill>
+        <p:spPr>
+          <a:xfrm>
+            <a:off x="4179473" y="0"/>
+            <a:ext cx="6885079" cy="3874915"/>
+          </a:xfrm>
+          <a:prstGeom prst="rect">
+            <a:avLst/>
+          </a:prstGeom>
+        </p:spPr>
+      </p:pic>
+      <p:grpSp>
+        <p:nvGrpSpPr>
+          <p:cNvPr id="44" name="群組 43">
+            <a:extLst>
+              <a:ext uri="{FF2B5EF4-FFF2-40B4-BE49-F238E27FC236}">
+                <a16:creationId xmlns:a16="http://schemas.microsoft.com/office/drawing/2014/main" id="{8F24FEFB-E948-6828-8820-A1BF738DBD54}"/>
+              </a:ext>
+            </a:extLst>
+          </p:cNvPr>
+          <p:cNvGrpSpPr/>
+          <p:nvPr/>
+        </p:nvGrpSpPr>
+        <p:grpSpPr>
+          <a:xfrm>
+            <a:off x="683120" y="4412921"/>
+            <a:ext cx="10525449" cy="1858978"/>
+            <a:chOff x="683120" y="4412921"/>
+            <a:chExt cx="10525449" cy="1858978"/>
+          </a:xfrm>
+        </p:grpSpPr>
+        <p:pic>
+          <p:nvPicPr>
+            <p:cNvPr id="10" name="圖片 9">
+              <a:extLst>
+                <a:ext uri="{FF2B5EF4-FFF2-40B4-BE49-F238E27FC236}">
+                  <a16:creationId xmlns:a16="http://schemas.microsoft.com/office/drawing/2014/main" id="{D1C34715-CD92-4EF6-E963-079FD2528172}"/>
+                </a:ext>
+              </a:extLst>
+            </p:cNvPr>
+            <p:cNvPicPr>
+              <a:picLocks noChangeAspect="1"/>
+            </p:cNvPicPr>
+            <p:nvPr/>
+          </p:nvPicPr>
+          <p:blipFill>
+            <a:blip r:embed="rId4">
+              <a:extLst>
+                <a:ext uri="{28A0092B-C50C-407E-A947-70E740481C1C}">
+                  <a14:useLocalDpi xmlns:a14="http://schemas.microsoft.com/office/drawing/2010/main" val="0"/>
+                </a:ext>
+              </a:extLst>
+            </a:blip>
+            <a:stretch>
+              <a:fillRect/>
+            </a:stretch>
+          </p:blipFill>
+          <p:spPr>
+            <a:xfrm>
+              <a:off x="5199497" y="4655880"/>
+              <a:ext cx="1492696" cy="1492696"/>
+            </a:xfrm>
+            <a:prstGeom prst="rect">
+              <a:avLst/>
+            </a:prstGeom>
+          </p:spPr>
+        </p:pic>
+        <p:pic>
+          <p:nvPicPr>
+            <p:cNvPr id="15" name="內容版面配置區 5">
+              <a:extLst>
+                <a:ext uri="{FF2B5EF4-FFF2-40B4-BE49-F238E27FC236}">
+                  <a16:creationId xmlns:a16="http://schemas.microsoft.com/office/drawing/2014/main" id="{87DCA9B4-EBF1-BD47-0670-3F0E8127A2E3}"/>
+                </a:ext>
+              </a:extLst>
+            </p:cNvPr>
+            <p:cNvPicPr>
+              <a:picLocks noChangeAspect="1"/>
+            </p:cNvPicPr>
+            <p:nvPr/>
+          </p:nvPicPr>
+          <p:blipFill>
+            <a:blip r:embed="rId5">
+              <a:extLst>
+                <a:ext uri="{28A0092B-C50C-407E-A947-70E740481C1C}">
+                  <a14:useLocalDpi xmlns:a14="http://schemas.microsoft.com/office/drawing/2010/main" val="0"/>
+                </a:ext>
+              </a:extLst>
+            </a:blip>
+            <a:stretch>
+              <a:fillRect/>
+            </a:stretch>
+          </p:blipFill>
+          <p:spPr>
+            <a:xfrm>
+              <a:off x="683120" y="4606166"/>
+              <a:ext cx="1592125" cy="1592125"/>
+            </a:xfrm>
+            <a:prstGeom prst="rect">
+              <a:avLst/>
+            </a:prstGeom>
+            <a:noFill/>
+          </p:spPr>
+        </p:pic>
+        <p:pic>
+          <p:nvPicPr>
+            <p:cNvPr id="13" name="內容版面配置區 5">
+              <a:extLst>
+                <a:ext uri="{FF2B5EF4-FFF2-40B4-BE49-F238E27FC236}">
+                  <a16:creationId xmlns:a16="http://schemas.microsoft.com/office/drawing/2014/main" id="{CE1408E1-ECF2-BDAC-ECA9-38EAD55EDF05}"/>
+                </a:ext>
+              </a:extLst>
+            </p:cNvPr>
+            <p:cNvPicPr>
+              <a:picLocks noChangeAspect="1"/>
+            </p:cNvPicPr>
+            <p:nvPr/>
+          </p:nvPicPr>
+          <p:blipFill>
+            <a:blip r:embed="rId5">
+              <a:extLst>
+                <a:ext uri="{28A0092B-C50C-407E-A947-70E740481C1C}">
+                  <a14:useLocalDpi xmlns:a14="http://schemas.microsoft.com/office/drawing/2010/main" val="0"/>
+                </a:ext>
+              </a:extLst>
+            </a:blip>
+            <a:stretch>
+              <a:fillRect/>
+            </a:stretch>
+          </p:blipFill>
+          <p:spPr>
+            <a:xfrm>
+              <a:off x="9616444" y="4606166"/>
+              <a:ext cx="1592125" cy="1592125"/>
+            </a:xfrm>
+            <a:prstGeom prst="rect">
+              <a:avLst/>
+            </a:prstGeom>
+            <a:noFill/>
+          </p:spPr>
+        </p:pic>
+        <p:cxnSp>
+          <p:nvCxnSpPr>
+            <p:cNvPr id="7" name="直線接點 6">
+              <a:extLst>
+                <a:ext uri="{FF2B5EF4-FFF2-40B4-BE49-F238E27FC236}">
+                  <a16:creationId xmlns:a16="http://schemas.microsoft.com/office/drawing/2014/main" id="{89E78668-A021-D738-3EF8-802EA919A37A}"/>
+                </a:ext>
+              </a:extLst>
+            </p:cNvPr>
+            <p:cNvCxnSpPr>
+              <a:cxnSpLocks/>
+            </p:cNvCxnSpPr>
+            <p:nvPr/>
+          </p:nvCxnSpPr>
+          <p:spPr>
+            <a:xfrm>
+              <a:off x="6763161" y="5376122"/>
+              <a:ext cx="2924251" cy="11622"/>
+            </a:xfrm>
+            <a:prstGeom prst="line">
+              <a:avLst/>
+            </a:prstGeom>
+            <a:ln w="19050">
+              <a:solidFill>
+                <a:schemeClr val="tx1"/>
+              </a:solidFill>
+              <a:prstDash val="dash"/>
+              <a:headEnd type="none" w="med" len="med"/>
+              <a:tailEnd type="triangle" w="med" len="med"/>
+            </a:ln>
+          </p:spPr>
+          <p:style>
+            <a:lnRef idx="1">
+              <a:schemeClr val="accent1"/>
+            </a:lnRef>
+            <a:fillRef idx="0">
+              <a:schemeClr val="accent1"/>
+            </a:fillRef>
+            <a:effectRef idx="0">
+              <a:schemeClr val="accent1"/>
+            </a:effectRef>
+            <a:fontRef idx="minor">
+              <a:schemeClr val="tx1"/>
+            </a:fontRef>
+          </p:style>
+        </p:cxnSp>
+        <p:cxnSp>
+          <p:nvCxnSpPr>
+            <p:cNvPr id="9" name="直線接點 8">
+              <a:extLst>
+                <a:ext uri="{FF2B5EF4-FFF2-40B4-BE49-F238E27FC236}">
+                  <a16:creationId xmlns:a16="http://schemas.microsoft.com/office/drawing/2014/main" id="{B8C16597-8B5A-3D23-22AC-962DAD576857}"/>
+                </a:ext>
+              </a:extLst>
+            </p:cNvPr>
+            <p:cNvCxnSpPr>
+              <a:cxnSpLocks/>
+            </p:cNvCxnSpPr>
+            <p:nvPr/>
+          </p:nvCxnSpPr>
+          <p:spPr>
+            <a:xfrm flipV="1">
+              <a:off x="2114771" y="4751322"/>
+              <a:ext cx="3013758" cy="16"/>
+            </a:xfrm>
+            <a:prstGeom prst="line">
+              <a:avLst/>
+            </a:prstGeom>
+            <a:ln w="19050">
+              <a:solidFill>
+                <a:schemeClr val="tx1"/>
+              </a:solidFill>
+              <a:prstDash val="dash"/>
+              <a:headEnd type="none" w="med" len="med"/>
+              <a:tailEnd type="arrow" w="med" len="med"/>
+            </a:ln>
+          </p:spPr>
+          <p:style>
+            <a:lnRef idx="1">
+              <a:schemeClr val="accent1"/>
+            </a:lnRef>
+            <a:fillRef idx="0">
+              <a:schemeClr val="accent1"/>
+            </a:fillRef>
+            <a:effectRef idx="0">
+              <a:schemeClr val="accent1"/>
+            </a:effectRef>
+            <a:fontRef idx="minor">
+              <a:schemeClr val="tx1"/>
+            </a:fontRef>
+          </p:style>
+        </p:cxnSp>
+        <p:cxnSp>
+          <p:nvCxnSpPr>
+            <p:cNvPr id="22" name="直線接點 21">
+              <a:extLst>
+                <a:ext uri="{FF2B5EF4-FFF2-40B4-BE49-F238E27FC236}">
+                  <a16:creationId xmlns:a16="http://schemas.microsoft.com/office/drawing/2014/main" id="{DA1EB34A-BF3B-B9E7-B67E-4E0B7FB756DB}"/>
+                </a:ext>
+              </a:extLst>
+            </p:cNvPr>
+            <p:cNvCxnSpPr>
+              <a:cxnSpLocks/>
+            </p:cNvCxnSpPr>
+            <p:nvPr/>
+          </p:nvCxnSpPr>
+          <p:spPr>
+            <a:xfrm flipH="1" flipV="1">
+              <a:off x="2114771" y="5181237"/>
+              <a:ext cx="3013758" cy="16"/>
+            </a:xfrm>
+            <a:prstGeom prst="line">
+              <a:avLst/>
+            </a:prstGeom>
+            <a:ln w="19050">
+              <a:solidFill>
+                <a:schemeClr val="tx1"/>
+              </a:solidFill>
+              <a:prstDash val="dash"/>
+              <a:headEnd type="none" w="med" len="med"/>
+              <a:tailEnd type="arrow" w="med" len="med"/>
+            </a:ln>
+          </p:spPr>
+          <p:style>
+            <a:lnRef idx="1">
+              <a:schemeClr val="accent1"/>
+            </a:lnRef>
+            <a:fillRef idx="0">
+              <a:schemeClr val="accent1"/>
+            </a:fillRef>
+            <a:effectRef idx="0">
+              <a:schemeClr val="accent1"/>
+            </a:effectRef>
+            <a:fontRef idx="minor">
+              <a:schemeClr val="tx1"/>
+            </a:fontRef>
+          </p:style>
+        </p:cxnSp>
+        <p:cxnSp>
+          <p:nvCxnSpPr>
+            <p:cNvPr id="23" name="直線接點 22">
+              <a:extLst>
+                <a:ext uri="{FF2B5EF4-FFF2-40B4-BE49-F238E27FC236}">
+                  <a16:creationId xmlns:a16="http://schemas.microsoft.com/office/drawing/2014/main" id="{01B8D763-F711-C376-7B22-DD3174469F91}"/>
+                </a:ext>
+              </a:extLst>
+            </p:cNvPr>
+            <p:cNvCxnSpPr>
+              <a:cxnSpLocks/>
+            </p:cNvCxnSpPr>
+            <p:nvPr/>
+          </p:nvCxnSpPr>
+          <p:spPr>
+            <a:xfrm flipV="1">
+              <a:off x="2114771" y="5611152"/>
+              <a:ext cx="3013758" cy="16"/>
+            </a:xfrm>
+            <a:prstGeom prst="line">
+              <a:avLst/>
+            </a:prstGeom>
+            <a:ln w="19050">
+              <a:solidFill>
+                <a:schemeClr val="tx1"/>
+              </a:solidFill>
+              <a:prstDash val="dash"/>
+              <a:headEnd type="none" w="med" len="med"/>
+              <a:tailEnd type="arrow" w="med" len="med"/>
+            </a:ln>
+          </p:spPr>
+          <p:style>
+            <a:lnRef idx="1">
+              <a:schemeClr val="accent1"/>
+            </a:lnRef>
+            <a:fillRef idx="0">
+              <a:schemeClr val="accent1"/>
+            </a:fillRef>
+            <a:effectRef idx="0">
+              <a:schemeClr val="accent1"/>
+            </a:effectRef>
+            <a:fontRef idx="minor">
+              <a:schemeClr val="tx1"/>
+            </a:fontRef>
+          </p:style>
+        </p:cxnSp>
+        <p:cxnSp>
+          <p:nvCxnSpPr>
+            <p:cNvPr id="24" name="直線接點 23">
+              <a:extLst>
+                <a:ext uri="{FF2B5EF4-FFF2-40B4-BE49-F238E27FC236}">
+                  <a16:creationId xmlns:a16="http://schemas.microsoft.com/office/drawing/2014/main" id="{8E3E8D74-23EA-EEB8-22B0-13A3E5B7F502}"/>
+                </a:ext>
+              </a:extLst>
+            </p:cNvPr>
+            <p:cNvCxnSpPr>
+              <a:cxnSpLocks/>
+            </p:cNvCxnSpPr>
+            <p:nvPr/>
+          </p:nvCxnSpPr>
+          <p:spPr>
+            <a:xfrm flipH="1" flipV="1">
+              <a:off x="2114771" y="6041068"/>
+              <a:ext cx="3013758" cy="16"/>
+            </a:xfrm>
+            <a:prstGeom prst="line">
+              <a:avLst/>
+            </a:prstGeom>
+            <a:ln w="19050">
+              <a:solidFill>
+                <a:schemeClr val="tx1"/>
+              </a:solidFill>
+              <a:prstDash val="dash"/>
+              <a:headEnd type="none" w="med" len="med"/>
+              <a:tailEnd type="arrow" w="med" len="med"/>
+            </a:ln>
+          </p:spPr>
+          <p:style>
+            <a:lnRef idx="1">
+              <a:schemeClr val="accent1"/>
+            </a:lnRef>
+            <a:fillRef idx="0">
+              <a:schemeClr val="accent1"/>
+            </a:fillRef>
+            <a:effectRef idx="0">
+              <a:schemeClr val="accent1"/>
+            </a:effectRef>
+            <a:fontRef idx="minor">
+              <a:schemeClr val="tx1"/>
+            </a:fontRef>
+          </p:style>
+        </p:cxnSp>
+        <p:sp>
+          <p:nvSpPr>
+            <p:cNvPr id="25" name="乘號 24">
+              <a:extLst>
+                <a:ext uri="{FF2B5EF4-FFF2-40B4-BE49-F238E27FC236}">
+                  <a16:creationId xmlns:a16="http://schemas.microsoft.com/office/drawing/2014/main" id="{2ADC5F1C-DA21-6D69-13F5-E4252A5A7618}"/>
+                </a:ext>
+              </a:extLst>
+            </p:cNvPr>
+            <p:cNvSpPr/>
+            <p:nvPr/>
+          </p:nvSpPr>
+          <p:spPr bwMode="auto">
+            <a:xfrm>
+              <a:off x="9620029" y="4412921"/>
+              <a:ext cx="914400" cy="914400"/>
+            </a:xfrm>
+            <a:prstGeom prst="mathMultiply">
+              <a:avLst/>
+            </a:prstGeom>
+            <a:solidFill>
+              <a:srgbClr val="FF0000"/>
+            </a:solidFill>
+            <a:ln w="9525" cap="flat" cmpd="sng" algn="ctr">
+              <a:solidFill>
+                <a:schemeClr val="tx1"/>
+              </a:solidFill>
+              <a:prstDash val="solid"/>
+              <a:round/>
+              <a:headEnd type="none" w="med" len="med"/>
+              <a:tailEnd type="none" w="med" len="med"/>
+            </a:ln>
+            <a:effectLst/>
+          </p:spPr>
+          <p:txBody>
+            <a:bodyPr vert="horz" wrap="square" lIns="91440" tIns="45720" rIns="91440" bIns="45720" numCol="1" rtlCol="0" anchor="t" anchorCtr="0" compatLnSpc="1">
+              <a:prstTxWarp prst="textNoShape">
+                <a:avLst/>
+              </a:prstTxWarp>
+            </a:bodyPr>
+            <a:lstStyle/>
+            <a:p>
+              <a:pPr marL="0" marR="0" indent="0" algn="l" defTabSz="914400" rtl="0" eaLnBrk="1" fontAlgn="base" latinLnBrk="0" hangingPunct="1">
+                <a:lnSpc>
+                  <a:spcPct val="100000"/>
+                </a:lnSpc>
+                <a:spcBef>
+                  <a:spcPct val="0"/>
+                </a:spcBef>
+                <a:spcAft>
+                  <a:spcPct val="0"/>
+                </a:spcAft>
+                <a:buClrTx/>
+                <a:buSzTx/>
+                <a:buFontTx/>
+                <a:buNone/>
+                <a:tabLst/>
+              </a:pPr>
+              <a:endParaRPr kumimoji="1" lang="zh-TW" altLang="en-US" sz="3600" b="0" i="0" u="none" strike="noStrike" cap="none" normalizeH="0" baseline="0">
+                <a:ln>
+                  <a:noFill/>
+                </a:ln>
+                <a:solidFill>
+                  <a:schemeClr val="tx2"/>
+                </a:solidFill>
+                <a:effectLst/>
+                <a:latin typeface="Times New Roman" pitchFamily="18" charset="0"/>
+                <a:ea typeface="標楷體" pitchFamily="65" charset="-120"/>
+              </a:endParaRPr>
+            </a:p>
+          </p:txBody>
+        </p:sp>
+        <p:sp>
+          <p:nvSpPr>
+            <p:cNvPr id="26" name="文字方塊 25">
+              <a:extLst>
+                <a:ext uri="{FF2B5EF4-FFF2-40B4-BE49-F238E27FC236}">
+                  <a16:creationId xmlns:a16="http://schemas.microsoft.com/office/drawing/2014/main" id="{02DEAADC-FD9F-C6CA-E6F1-A67F1E247410}"/>
+                </a:ext>
+              </a:extLst>
+            </p:cNvPr>
+            <p:cNvSpPr txBox="1"/>
+            <p:nvPr/>
+          </p:nvSpPr>
+          <p:spPr>
+            <a:xfrm>
+              <a:off x="3125774" y="4439939"/>
+              <a:ext cx="1002848" cy="461665"/>
+            </a:xfrm>
+            <a:prstGeom prst="rect">
+              <a:avLst/>
+            </a:prstGeom>
+            <a:solidFill>
+              <a:schemeClr val="bg1"/>
+            </a:solidFill>
+          </p:spPr>
+          <p:txBody>
+            <a:bodyPr wrap="square" rtlCol="0" anchor="ctr">
+              <a:spAutoFit/>
+            </a:bodyPr>
+            <a:lstStyle/>
+            <a:p>
+              <a:pPr algn="ctr"/>
+              <a:r>
+                <a:rPr lang="en-US" altLang="zh-TW" sz="2400" dirty="0">
+                  <a:latin typeface="Calibri" panose="020F0502020204030204" pitchFamily="34" charset="0"/>
+                  <a:ea typeface="Calibri" panose="020F0502020204030204" pitchFamily="34" charset="0"/>
+                  <a:cs typeface="Calibri" panose="020F0502020204030204" pitchFamily="34" charset="0"/>
+                </a:rPr>
+                <a:t>1. RTS</a:t>
+              </a:r>
+              <a:endParaRPr lang="zh-TW" altLang="en-US" sz="2400" dirty="0">
+                <a:latin typeface="Calibri" panose="020F0502020204030204" pitchFamily="34" charset="0"/>
+                <a:ea typeface="Calibri" panose="020F0502020204030204" pitchFamily="34" charset="0"/>
+                <a:cs typeface="Calibri" panose="020F0502020204030204" pitchFamily="34" charset="0"/>
+              </a:endParaRPr>
+            </a:p>
+          </p:txBody>
+        </p:sp>
+        <p:sp>
+          <p:nvSpPr>
+            <p:cNvPr id="35" name="文字方塊 34">
+              <a:extLst>
+                <a:ext uri="{FF2B5EF4-FFF2-40B4-BE49-F238E27FC236}">
+                  <a16:creationId xmlns:a16="http://schemas.microsoft.com/office/drawing/2014/main" id="{9445FC50-601C-D5B8-5EDF-8B3B26827A35}"/>
+                </a:ext>
+              </a:extLst>
+            </p:cNvPr>
+            <p:cNvSpPr txBox="1"/>
+            <p:nvPr/>
+          </p:nvSpPr>
+          <p:spPr>
+            <a:xfrm>
+              <a:off x="3125774" y="4926079"/>
+              <a:ext cx="1002848" cy="461665"/>
+            </a:xfrm>
+            <a:prstGeom prst="rect">
+              <a:avLst/>
+            </a:prstGeom>
+            <a:solidFill>
+              <a:schemeClr val="bg1"/>
+            </a:solidFill>
+          </p:spPr>
+          <p:txBody>
+            <a:bodyPr wrap="square" rtlCol="0" anchor="ctr">
+              <a:spAutoFit/>
+            </a:bodyPr>
+            <a:lstStyle/>
+            <a:p>
+              <a:pPr algn="ctr"/>
+              <a:r>
+                <a:rPr lang="en-US" altLang="zh-TW" sz="2400" dirty="0">
+                  <a:latin typeface="Calibri" panose="020F0502020204030204" pitchFamily="34" charset="0"/>
+                  <a:ea typeface="Calibri" panose="020F0502020204030204" pitchFamily="34" charset="0"/>
+                  <a:cs typeface="Calibri" panose="020F0502020204030204" pitchFamily="34" charset="0"/>
+                </a:rPr>
+                <a:t>2. CTS</a:t>
+              </a:r>
+              <a:endParaRPr lang="zh-TW" altLang="en-US" sz="2400" dirty="0">
+                <a:latin typeface="Calibri" panose="020F0502020204030204" pitchFamily="34" charset="0"/>
+                <a:ea typeface="Calibri" panose="020F0502020204030204" pitchFamily="34" charset="0"/>
+                <a:cs typeface="Calibri" panose="020F0502020204030204" pitchFamily="34" charset="0"/>
+              </a:endParaRPr>
+            </a:p>
+          </p:txBody>
+        </p:sp>
+        <p:sp>
+          <p:nvSpPr>
+            <p:cNvPr id="37" name="文字方塊 36">
+              <a:extLst>
+                <a:ext uri="{FF2B5EF4-FFF2-40B4-BE49-F238E27FC236}">
+                  <a16:creationId xmlns:a16="http://schemas.microsoft.com/office/drawing/2014/main" id="{6DA75034-86A3-89B3-C452-1C71C7909568}"/>
+                </a:ext>
+              </a:extLst>
+            </p:cNvPr>
+            <p:cNvSpPr txBox="1"/>
+            <p:nvPr/>
+          </p:nvSpPr>
+          <p:spPr>
+            <a:xfrm>
+              <a:off x="2880851" y="5371861"/>
+              <a:ext cx="1492695" cy="461665"/>
+            </a:xfrm>
+            <a:prstGeom prst="rect">
+              <a:avLst/>
+            </a:prstGeom>
+            <a:solidFill>
+              <a:schemeClr val="bg1"/>
+            </a:solidFill>
+          </p:spPr>
+          <p:txBody>
+            <a:bodyPr wrap="square" rtlCol="0" anchor="ctr">
+              <a:spAutoFit/>
+            </a:bodyPr>
+            <a:lstStyle/>
+            <a:p>
+              <a:pPr algn="ctr"/>
+              <a:r>
+                <a:rPr lang="en-US" altLang="zh-TW" sz="2400" dirty="0">
+                  <a:latin typeface="Calibri" panose="020F0502020204030204" pitchFamily="34" charset="0"/>
+                  <a:ea typeface="Calibri" panose="020F0502020204030204" pitchFamily="34" charset="0"/>
+                  <a:cs typeface="Calibri" panose="020F0502020204030204" pitchFamily="34" charset="0"/>
+                </a:rPr>
+                <a:t>4. DATA</a:t>
+              </a:r>
+              <a:endParaRPr lang="zh-TW" altLang="en-US" sz="2400" dirty="0">
+                <a:latin typeface="Calibri" panose="020F0502020204030204" pitchFamily="34" charset="0"/>
+                <a:ea typeface="Calibri" panose="020F0502020204030204" pitchFamily="34" charset="0"/>
+                <a:cs typeface="Calibri" panose="020F0502020204030204" pitchFamily="34" charset="0"/>
+              </a:endParaRPr>
+            </a:p>
+          </p:txBody>
+        </p:sp>
+        <p:sp>
+          <p:nvSpPr>
+            <p:cNvPr id="39" name="文字方塊 38">
+              <a:extLst>
+                <a:ext uri="{FF2B5EF4-FFF2-40B4-BE49-F238E27FC236}">
+                  <a16:creationId xmlns:a16="http://schemas.microsoft.com/office/drawing/2014/main" id="{BF62DC32-75D3-366C-6191-9F703C15AE94}"/>
+                </a:ext>
+              </a:extLst>
+            </p:cNvPr>
+            <p:cNvSpPr txBox="1"/>
+            <p:nvPr/>
+          </p:nvSpPr>
+          <p:spPr>
+            <a:xfrm>
+              <a:off x="3125774" y="5810234"/>
+              <a:ext cx="1002848" cy="461665"/>
+            </a:xfrm>
+            <a:prstGeom prst="rect">
+              <a:avLst/>
+            </a:prstGeom>
+            <a:solidFill>
+              <a:schemeClr val="bg1"/>
+            </a:solidFill>
+          </p:spPr>
+          <p:txBody>
+            <a:bodyPr wrap="square" rtlCol="0" anchor="ctr">
+              <a:spAutoFit/>
+            </a:bodyPr>
+            <a:lstStyle/>
+            <a:p>
+              <a:pPr algn="ctr"/>
+              <a:r>
+                <a:rPr lang="en-US" altLang="zh-TW" sz="2400" dirty="0">
+                  <a:latin typeface="Calibri" panose="020F0502020204030204" pitchFamily="34" charset="0"/>
+                  <a:ea typeface="Calibri" panose="020F0502020204030204" pitchFamily="34" charset="0"/>
+                  <a:cs typeface="Calibri" panose="020F0502020204030204" pitchFamily="34" charset="0"/>
+                </a:rPr>
+                <a:t>5. ACK</a:t>
+              </a:r>
+              <a:endParaRPr lang="zh-TW" altLang="en-US" sz="2400" dirty="0">
+                <a:latin typeface="Calibri" panose="020F0502020204030204" pitchFamily="34" charset="0"/>
+                <a:ea typeface="Calibri" panose="020F0502020204030204" pitchFamily="34" charset="0"/>
+                <a:cs typeface="Calibri" panose="020F0502020204030204" pitchFamily="34" charset="0"/>
+              </a:endParaRPr>
+            </a:p>
+          </p:txBody>
+        </p:sp>
+        <p:sp>
+          <p:nvSpPr>
+            <p:cNvPr id="43" name="文字方塊 42">
+              <a:extLst>
+                <a:ext uri="{FF2B5EF4-FFF2-40B4-BE49-F238E27FC236}">
+                  <a16:creationId xmlns:a16="http://schemas.microsoft.com/office/drawing/2014/main" id="{D6564755-B0C2-1B87-E15E-1EDFFDB110A3}"/>
+                </a:ext>
+              </a:extLst>
+            </p:cNvPr>
+            <p:cNvSpPr txBox="1"/>
+            <p:nvPr/>
+          </p:nvSpPr>
+          <p:spPr>
+            <a:xfrm>
+              <a:off x="7723862" y="5181237"/>
+              <a:ext cx="1002848" cy="461665"/>
+            </a:xfrm>
+            <a:prstGeom prst="rect">
+              <a:avLst/>
+            </a:prstGeom>
+            <a:solidFill>
+              <a:schemeClr val="bg1"/>
+            </a:solidFill>
+          </p:spPr>
+          <p:txBody>
+            <a:bodyPr wrap="square" rtlCol="0" anchor="ctr">
+              <a:spAutoFit/>
+            </a:bodyPr>
+            <a:lstStyle/>
+            <a:p>
+              <a:pPr algn="ctr"/>
+              <a:r>
+                <a:rPr lang="en-US" altLang="zh-TW" sz="2400" dirty="0">
+                  <a:latin typeface="Calibri" panose="020F0502020204030204" pitchFamily="34" charset="0"/>
+                  <a:ea typeface="Calibri" panose="020F0502020204030204" pitchFamily="34" charset="0"/>
+                  <a:cs typeface="Calibri" panose="020F0502020204030204" pitchFamily="34" charset="0"/>
+                </a:rPr>
+                <a:t>2. CTS</a:t>
+              </a:r>
+              <a:endParaRPr lang="zh-TW" altLang="en-US" sz="2400" dirty="0">
+                <a:latin typeface="Calibri" panose="020F0502020204030204" pitchFamily="34" charset="0"/>
+                <a:ea typeface="Calibri" panose="020F0502020204030204" pitchFamily="34" charset="0"/>
+                <a:cs typeface="Calibri" panose="020F0502020204030204" pitchFamily="34" charset="0"/>
+              </a:endParaRPr>
+            </a:p>
+          </p:txBody>
+        </p:sp>
+      </p:grpSp>
+    </p:spTree>
+    <p:extLst>
+      <p:ext uri="{BB962C8B-B14F-4D97-AF65-F5344CB8AC3E}">
+        <p14:creationId xmlns:p14="http://schemas.microsoft.com/office/powerpoint/2010/main" val="2879500545"/>
       </p:ext>
     </p:extLst>
   </p:cSld>
@@ -12889,7 +14122,7 @@
           <a:p>
             <a:r>
               <a:rPr lang="en-US" altLang="zh-TW" dirty="0"/>
-              <a:t>Hidden Nodes Cause Receiver-Side Collisions</a:t>
+              <a:t>Hidden Nodes Problem</a:t>
             </a:r>
             <a:endParaRPr dirty="0"/>
           </a:p>
@@ -12958,34 +14191,40 @@
           <a:p>
             <a:r>
               <a:rPr lang="en-US" altLang="zh-TW" dirty="0"/>
-              <a:t>Hidden node reaches AP but cannot sense other nodes using same AP</a:t>
-            </a:r>
-          </a:p>
-          <a:p>
+              <a:t>D</a:t>
+            </a:r>
+            <a:r>
+              <a:rPr lang="zh-TW" altLang="zh-TW" dirty="0"/>
+              <a:t>evices</a:t>
+            </a:r>
+            <a:r>
+              <a:rPr lang="zh-TW" altLang="en-US" dirty="0"/>
+              <a:t> </a:t>
+            </a:r>
+            <a:r>
+              <a:rPr lang="zh-TW" altLang="zh-TW" dirty="0"/>
+              <a:t>can communicate with AP but cannot detect each other</a:t>
+            </a:r>
+            <a:endParaRPr lang="en-US" altLang="zh-TW" dirty="0"/>
+          </a:p>
+          <a:p>
+            <a:r>
+              <a:rPr lang="zh-TW" altLang="zh-TW" dirty="0"/>
+              <a:t>When they transmit at the same time, their signals collide at the AP</a:t>
+            </a:r>
+            <a:endParaRPr lang="en-US" altLang="zh-TW" dirty="0"/>
+          </a:p>
+          <a:p>
+            <a:pPr lvl="1"/>
             <a:r>
               <a:rPr lang="en-US" altLang="zh-TW" dirty="0"/>
-              <a:t>Nodes cannot hear each other</a:t>
-            </a:r>
-          </a:p>
-          <a:p>
-            <a:pPr lvl="1"/>
-            <a:r>
-              <a:rPr lang="en-US" altLang="zh-TW" dirty="0"/>
-              <a:t>May transmit simultaneously</a:t>
-            </a:r>
-          </a:p>
-          <a:p>
-            <a:r>
-              <a:rPr lang="en-US" altLang="zh-TW" dirty="0"/>
-              <a:t>Simultaneous transmissions collide at AP</a:t>
-            </a:r>
-          </a:p>
-          <a:p>
-            <a:pPr lvl="1"/>
-            <a:r>
-              <a:rPr lang="en-US" altLang="zh-TW" dirty="0"/>
-              <a:t>Reduces wireless network throughput</a:t>
-            </a:r>
+              <a:t>C</a:t>
+            </a:r>
+            <a:r>
+              <a:rPr lang="zh-TW" altLang="zh-TW" dirty="0"/>
+              <a:t>auses packet loss and lower throughput</a:t>
+            </a:r>
+            <a:endParaRPr lang="en-US" altLang="zh-TW" dirty="0"/>
           </a:p>
         </p:txBody>
       </p:sp>
@@ -13003,7 +14242,7 @@
         </p:nvGrpSpPr>
         <p:grpSpPr>
           <a:xfrm>
-            <a:off x="5523554" y="3080581"/>
+            <a:off x="3040250" y="2824942"/>
             <a:ext cx="6255516" cy="3356964"/>
             <a:chOff x="2864188" y="3407243"/>
             <a:chExt cx="6255516" cy="3356964"/>
@@ -13465,48 +14704,96 @@
             </a:r>
             <a:r>
               <a:rPr lang="zh-TW" altLang="zh-TW" dirty="0"/>
-              <a:t>ptional 802.11 handshake before data transmission.</a:t>
+              <a:t>ptional 802.11 handshake before data transmission</a:t>
             </a:r>
             <a:endParaRPr lang="en-US" altLang="zh-TW" dirty="0"/>
           </a:p>
           <a:p>
             <a:r>
               <a:rPr lang="zh-TW" altLang="zh-TW" dirty="0"/>
-              <a:t>Sender sends RTS to request channel access.</a:t>
+              <a:t>RTS/CTS makes nearby nodes defer, reducing hidden-node collisions</a:t>
             </a:r>
             <a:endParaRPr lang="en-US" altLang="zh-TW" dirty="0"/>
           </a:p>
           <a:p>
             <a:r>
+              <a:rPr lang="en-US" altLang="zh-TW" dirty="0"/>
+              <a:t>Step:</a:t>
+            </a:r>
+          </a:p>
+          <a:p>
+            <a:pPr marL="745200" lvl="1" indent="-457200">
+              <a:buFont typeface="+mj-lt"/>
+              <a:buAutoNum type="arabicPeriod"/>
+            </a:pPr>
+            <a:r>
               <a:rPr lang="zh-TW" altLang="zh-TW" dirty="0"/>
-              <a:t>Receiver sends CTS to grant transmission permission.</a:t>
+              <a:t>Sender sends RTS to request channel access</a:t>
             </a:r>
             <a:endParaRPr lang="en-US" altLang="zh-TW" dirty="0"/>
           </a:p>
           <a:p>
+            <a:pPr lvl="2"/>
             <a:r>
               <a:rPr lang="zh-TW" altLang="zh-TW" dirty="0"/>
-              <a:t>Nearby nodes that hear RTS or CTS update NAV and defer.</a:t>
+              <a:t>Nearby node that hear </a:t>
+            </a:r>
+            <a:r>
+              <a:rPr lang="en-US" altLang="zh-TW" dirty="0"/>
+              <a:t>RTS</a:t>
+            </a:r>
+            <a:r>
+              <a:rPr lang="zh-TW" altLang="en-US" dirty="0"/>
+              <a:t> </a:t>
+            </a:r>
+            <a:r>
+              <a:rPr lang="zh-TW" altLang="zh-TW" dirty="0"/>
+              <a:t>defer</a:t>
             </a:r>
             <a:endParaRPr lang="en-US" altLang="zh-TW" dirty="0"/>
           </a:p>
           <a:p>
+            <a:pPr marL="745200" lvl="1" indent="-457200">
+              <a:buFont typeface="+mj-lt"/>
+              <a:buAutoNum type="arabicPeriod"/>
+            </a:pPr>
+            <a:r>
+              <a:rPr lang="en-US" altLang="zh-TW" dirty="0"/>
+              <a:t>AP</a:t>
+            </a:r>
             <a:r>
               <a:rPr lang="zh-TW" altLang="zh-TW" dirty="0"/>
-              <a:t>Hidden nodes may miss RTS but still hear CTS from the receiver.</a:t>
+              <a:t> sends CTS to grant transmission permission</a:t>
             </a:r>
             <a:endParaRPr lang="en-US" altLang="zh-TW" dirty="0"/>
           </a:p>
           <a:p>
+            <a:pPr lvl="2"/>
+            <a:r>
+              <a:rPr lang="zh-TW" altLang="zh-TW" dirty="0"/>
+              <a:t>Hidden node</a:t>
+            </a:r>
             <a:r>
               <a:rPr lang="en-US" altLang="zh-TW" dirty="0"/>
-              <a:t>Sender transmits data after the channel is reserved.</a:t>
-            </a:r>
-          </a:p>
-          <a:p>
+              <a:t> </a:t>
+            </a:r>
             <a:r>
               <a:rPr lang="zh-TW" altLang="zh-TW" dirty="0"/>
-              <a:t>Reserving the receiver's neighborhood reduces hidden-node collisions.</a:t>
+              <a:t>hear CTS </a:t>
+            </a:r>
+            <a:r>
+              <a:rPr lang="en-US" altLang="zh-TW" dirty="0"/>
+              <a:t> defer</a:t>
+            </a:r>
+          </a:p>
+          <a:p>
+            <a:pPr marL="745200" lvl="1" indent="-457200">
+              <a:buFont typeface="+mj-lt"/>
+              <a:buAutoNum type="arabicPeriod"/>
+            </a:pPr>
+            <a:r>
+              <a:rPr lang="en-US" altLang="zh-TW" dirty="0"/>
+              <a:t>Sender transmits data after the channel is reserved</a:t>
             </a:r>
           </a:p>
         </p:txBody>
@@ -13553,10 +14840,10 @@
       </p:sp>
       <p:pic>
         <p:nvPicPr>
-          <p:cNvPr id="8" name="圖片 7">
+          <p:cNvPr id="37" name="內容版面配置區 5">
             <a:extLst>
               <a:ext uri="{FF2B5EF4-FFF2-40B4-BE49-F238E27FC236}">
-                <a16:creationId xmlns:a16="http://schemas.microsoft.com/office/drawing/2014/main" id="{248C459E-E296-531E-6CCD-6F0C86BABD8B}"/>
+                <a16:creationId xmlns:a16="http://schemas.microsoft.com/office/drawing/2014/main" id="{BE4002B0-05F5-24BC-43DE-8D1C795535C5}"/>
               </a:ext>
             </a:extLst>
           </p:cNvPr>
@@ -13579,14 +14866,1034 @@
         </p:blipFill>
         <p:spPr>
           <a:xfrm>
-            <a:off x="7482348" y="4216853"/>
-            <a:ext cx="3784424" cy="2129870"/>
+            <a:off x="10250558" y="4845419"/>
+            <a:ext cx="1592125" cy="1592125"/>
+          </a:xfrm>
+          <a:prstGeom prst="rect">
+            <a:avLst/>
+          </a:prstGeom>
+          <a:noFill/>
+        </p:spPr>
+      </p:pic>
+      <p:pic>
+        <p:nvPicPr>
+          <p:cNvPr id="6" name="圖片 5">
+            <a:extLst>
+              <a:ext uri="{FF2B5EF4-FFF2-40B4-BE49-F238E27FC236}">
+                <a16:creationId xmlns:a16="http://schemas.microsoft.com/office/drawing/2014/main" id="{408FBFEB-86BB-0F6F-AF14-AFB5AA687C03}"/>
+              </a:ext>
+            </a:extLst>
+          </p:cNvPr>
+          <p:cNvPicPr>
+            <a:picLocks noChangeAspect="1"/>
+          </p:cNvPicPr>
+          <p:nvPr/>
+        </p:nvPicPr>
+        <p:blipFill>
+          <a:blip r:embed="rId4">
+            <a:extLst>
+              <a:ext uri="{28A0092B-C50C-407E-A947-70E740481C1C}">
+                <a14:useLocalDpi xmlns:a14="http://schemas.microsoft.com/office/drawing/2010/main" val="0"/>
+              </a:ext>
+            </a:extLst>
+          </a:blip>
+          <a:stretch>
+            <a:fillRect/>
+          </a:stretch>
+        </p:blipFill>
+        <p:spPr>
+          <a:xfrm>
+            <a:off x="6524175" y="4895134"/>
+            <a:ext cx="1492696" cy="1492696"/>
           </a:xfrm>
           <a:prstGeom prst="rect">
             <a:avLst/>
           </a:prstGeom>
         </p:spPr>
       </p:pic>
+      <p:pic>
+        <p:nvPicPr>
+          <p:cNvPr id="7" name="內容版面配置區 5">
+            <a:extLst>
+              <a:ext uri="{FF2B5EF4-FFF2-40B4-BE49-F238E27FC236}">
+                <a16:creationId xmlns:a16="http://schemas.microsoft.com/office/drawing/2014/main" id="{85E5E06E-7868-F095-29F7-BC1065177181}"/>
+              </a:ext>
+            </a:extLst>
+          </p:cNvPr>
+          <p:cNvPicPr>
+            <a:picLocks noChangeAspect="1"/>
+          </p:cNvPicPr>
+          <p:nvPr/>
+        </p:nvPicPr>
+        <p:blipFill>
+          <a:blip r:embed="rId3">
+            <a:extLst>
+              <a:ext uri="{28A0092B-C50C-407E-A947-70E740481C1C}">
+                <a14:useLocalDpi xmlns:a14="http://schemas.microsoft.com/office/drawing/2010/main" val="0"/>
+              </a:ext>
+            </a:extLst>
+          </a:blip>
+          <a:stretch>
+            <a:fillRect/>
+          </a:stretch>
+        </p:blipFill>
+        <p:spPr>
+          <a:xfrm>
+            <a:off x="2860601" y="4845420"/>
+            <a:ext cx="1592125" cy="1592125"/>
+          </a:xfrm>
+          <a:prstGeom prst="rect">
+            <a:avLst/>
+          </a:prstGeom>
+          <a:noFill/>
+        </p:spPr>
+      </p:pic>
+      <p:sp>
+        <p:nvSpPr>
+          <p:cNvPr id="15" name="乘號 14">
+            <a:extLst>
+              <a:ext uri="{FF2B5EF4-FFF2-40B4-BE49-F238E27FC236}">
+                <a16:creationId xmlns:a16="http://schemas.microsoft.com/office/drawing/2014/main" id="{B71CBB7F-6DC9-B75C-1780-EC99C1665C88}"/>
+              </a:ext>
+            </a:extLst>
+          </p:cNvPr>
+          <p:cNvSpPr/>
+          <p:nvPr/>
+        </p:nvSpPr>
+        <p:spPr bwMode="auto">
+          <a:xfrm>
+            <a:off x="10123807" y="4652175"/>
+            <a:ext cx="914400" cy="914400"/>
+          </a:xfrm>
+          <a:prstGeom prst="mathMultiply">
+            <a:avLst/>
+          </a:prstGeom>
+          <a:solidFill>
+            <a:srgbClr val="FF0000"/>
+          </a:solidFill>
+          <a:ln w="9525" cap="flat" cmpd="sng" algn="ctr">
+            <a:solidFill>
+              <a:schemeClr val="tx1"/>
+            </a:solidFill>
+            <a:prstDash val="solid"/>
+            <a:round/>
+            <a:headEnd type="none" w="med" len="med"/>
+            <a:tailEnd type="none" w="med" len="med"/>
+          </a:ln>
+          <a:effectLst/>
+        </p:spPr>
+        <p:txBody>
+          <a:bodyPr vert="horz" wrap="square" lIns="91440" tIns="45720" rIns="91440" bIns="45720" numCol="1" rtlCol="0" anchor="t" anchorCtr="0" compatLnSpc="1">
+            <a:prstTxWarp prst="textNoShape">
+              <a:avLst/>
+            </a:prstTxWarp>
+          </a:bodyPr>
+          <a:lstStyle/>
+          <a:p>
+            <a:pPr marL="0" marR="0" indent="0" algn="l" defTabSz="914400" rtl="0" eaLnBrk="1" fontAlgn="base" latinLnBrk="0" hangingPunct="1">
+              <a:lnSpc>
+                <a:spcPct val="100000"/>
+              </a:lnSpc>
+              <a:spcBef>
+                <a:spcPct val="0"/>
+              </a:spcBef>
+              <a:spcAft>
+                <a:spcPct val="0"/>
+              </a:spcAft>
+              <a:buClrTx/>
+              <a:buSzTx/>
+              <a:buFontTx/>
+              <a:buNone/>
+              <a:tabLst/>
+            </a:pPr>
+            <a:endParaRPr kumimoji="1" lang="zh-TW" altLang="en-US" sz="3600" b="0" i="0" u="none" strike="noStrike" cap="none" normalizeH="0" baseline="0">
+              <a:ln>
+                <a:noFill/>
+              </a:ln>
+              <a:solidFill>
+                <a:schemeClr val="tx2"/>
+              </a:solidFill>
+              <a:effectLst/>
+              <a:latin typeface="Times New Roman" pitchFamily="18" charset="0"/>
+              <a:ea typeface="標楷體" pitchFamily="65" charset="-120"/>
+            </a:endParaRPr>
+          </a:p>
+        </p:txBody>
+      </p:sp>
+      <p:grpSp>
+        <p:nvGrpSpPr>
+          <p:cNvPr id="61" name="群組 60">
+            <a:extLst>
+              <a:ext uri="{FF2B5EF4-FFF2-40B4-BE49-F238E27FC236}">
+                <a16:creationId xmlns:a16="http://schemas.microsoft.com/office/drawing/2014/main" id="{072EE419-6040-C4E7-3DA2-11CB8999AD13}"/>
+              </a:ext>
+            </a:extLst>
+          </p:cNvPr>
+          <p:cNvGrpSpPr/>
+          <p:nvPr/>
+        </p:nvGrpSpPr>
+        <p:grpSpPr>
+          <a:xfrm>
+            <a:off x="1023065" y="4806537"/>
+            <a:ext cx="2145564" cy="461665"/>
+            <a:chOff x="3434887" y="4679193"/>
+            <a:chExt cx="2197420" cy="461665"/>
+          </a:xfrm>
+        </p:grpSpPr>
+        <p:cxnSp>
+          <p:nvCxnSpPr>
+            <p:cNvPr id="11" name="直線接點 10">
+              <a:extLst>
+                <a:ext uri="{FF2B5EF4-FFF2-40B4-BE49-F238E27FC236}">
+                  <a16:creationId xmlns:a16="http://schemas.microsoft.com/office/drawing/2014/main" id="{8FF64304-0A77-F79F-5F50-8A0702D0EAE8}"/>
+                </a:ext>
+              </a:extLst>
+            </p:cNvPr>
+            <p:cNvCxnSpPr>
+              <a:cxnSpLocks/>
+            </p:cNvCxnSpPr>
+            <p:nvPr/>
+          </p:nvCxnSpPr>
+          <p:spPr>
+            <a:xfrm flipH="1">
+              <a:off x="3434887" y="4910017"/>
+              <a:ext cx="2197420" cy="0"/>
+            </a:xfrm>
+            <a:prstGeom prst="line">
+              <a:avLst/>
+            </a:prstGeom>
+            <a:ln w="19050">
+              <a:solidFill>
+                <a:schemeClr val="tx1"/>
+              </a:solidFill>
+              <a:prstDash val="dash"/>
+              <a:headEnd type="none" w="med" len="med"/>
+              <a:tailEnd type="arrow" w="med" len="med"/>
+            </a:ln>
+          </p:spPr>
+          <p:style>
+            <a:lnRef idx="1">
+              <a:schemeClr val="accent1"/>
+            </a:lnRef>
+            <a:fillRef idx="0">
+              <a:schemeClr val="accent1"/>
+            </a:fillRef>
+            <a:effectRef idx="0">
+              <a:schemeClr val="accent1"/>
+            </a:effectRef>
+            <a:fontRef idx="minor">
+              <a:schemeClr val="tx1"/>
+            </a:fontRef>
+          </p:style>
+        </p:cxnSp>
+        <p:sp>
+          <p:nvSpPr>
+            <p:cNvPr id="16" name="文字方塊 15">
+              <a:extLst>
+                <a:ext uri="{FF2B5EF4-FFF2-40B4-BE49-F238E27FC236}">
+                  <a16:creationId xmlns:a16="http://schemas.microsoft.com/office/drawing/2014/main" id="{457F2047-660C-E84E-378E-2E011EE328F9}"/>
+                </a:ext>
+              </a:extLst>
+            </p:cNvPr>
+            <p:cNvSpPr txBox="1"/>
+            <p:nvPr/>
+          </p:nvSpPr>
+          <p:spPr>
+            <a:xfrm flipH="1">
+              <a:off x="4001703" y="4679193"/>
+              <a:ext cx="1029990" cy="461665"/>
+            </a:xfrm>
+            <a:prstGeom prst="rect">
+              <a:avLst/>
+            </a:prstGeom>
+            <a:solidFill>
+              <a:schemeClr val="bg1"/>
+            </a:solidFill>
+          </p:spPr>
+          <p:txBody>
+            <a:bodyPr wrap="square" rtlCol="0" anchor="ctr">
+              <a:spAutoFit/>
+            </a:bodyPr>
+            <a:lstStyle/>
+            <a:p>
+              <a:pPr algn="ctr"/>
+              <a:r>
+                <a:rPr lang="en-US" altLang="zh-TW" sz="2400" dirty="0">
+                  <a:latin typeface="Calibri" panose="020F0502020204030204" pitchFamily="34" charset="0"/>
+                  <a:ea typeface="Calibri" panose="020F0502020204030204" pitchFamily="34" charset="0"/>
+                  <a:cs typeface="Calibri" panose="020F0502020204030204" pitchFamily="34" charset="0"/>
+                </a:rPr>
+                <a:t>1. RTS</a:t>
+              </a:r>
+              <a:endParaRPr lang="zh-TW" altLang="en-US" sz="2400" dirty="0">
+                <a:latin typeface="Calibri" panose="020F0502020204030204" pitchFamily="34" charset="0"/>
+                <a:ea typeface="Calibri" panose="020F0502020204030204" pitchFamily="34" charset="0"/>
+                <a:cs typeface="Calibri" panose="020F0502020204030204" pitchFamily="34" charset="0"/>
+              </a:endParaRPr>
+            </a:p>
+          </p:txBody>
+        </p:sp>
+      </p:grpSp>
+      <p:grpSp>
+        <p:nvGrpSpPr>
+          <p:cNvPr id="62" name="群組 61">
+            <a:extLst>
+              <a:ext uri="{FF2B5EF4-FFF2-40B4-BE49-F238E27FC236}">
+                <a16:creationId xmlns:a16="http://schemas.microsoft.com/office/drawing/2014/main" id="{F81BFEA1-7ABC-1013-F912-3579711DCB40}"/>
+              </a:ext>
+            </a:extLst>
+          </p:cNvPr>
+          <p:cNvGrpSpPr/>
+          <p:nvPr/>
+        </p:nvGrpSpPr>
+        <p:grpSpPr>
+          <a:xfrm>
+            <a:off x="4227040" y="5410432"/>
+            <a:ext cx="2197420" cy="461665"/>
+            <a:chOff x="3434887" y="5325684"/>
+            <a:chExt cx="2197420" cy="461665"/>
+          </a:xfrm>
+        </p:grpSpPr>
+        <p:cxnSp>
+          <p:nvCxnSpPr>
+            <p:cNvPr id="12" name="直線接點 11">
+              <a:extLst>
+                <a:ext uri="{FF2B5EF4-FFF2-40B4-BE49-F238E27FC236}">
+                  <a16:creationId xmlns:a16="http://schemas.microsoft.com/office/drawing/2014/main" id="{9B858A10-FE34-4FB2-78D3-09A598E3F077}"/>
+                </a:ext>
+              </a:extLst>
+            </p:cNvPr>
+            <p:cNvCxnSpPr>
+              <a:cxnSpLocks/>
+            </p:cNvCxnSpPr>
+            <p:nvPr/>
+          </p:nvCxnSpPr>
+          <p:spPr>
+            <a:xfrm flipH="1">
+              <a:off x="3434887" y="5556524"/>
+              <a:ext cx="2197420" cy="0"/>
+            </a:xfrm>
+            <a:prstGeom prst="line">
+              <a:avLst/>
+            </a:prstGeom>
+            <a:ln w="19050">
+              <a:solidFill>
+                <a:schemeClr val="tx1"/>
+              </a:solidFill>
+              <a:prstDash val="dash"/>
+              <a:headEnd type="none" w="med" len="med"/>
+              <a:tailEnd type="arrow" w="med" len="med"/>
+            </a:ln>
+          </p:spPr>
+          <p:style>
+            <a:lnRef idx="1">
+              <a:schemeClr val="accent1"/>
+            </a:lnRef>
+            <a:fillRef idx="0">
+              <a:schemeClr val="accent1"/>
+            </a:fillRef>
+            <a:effectRef idx="0">
+              <a:schemeClr val="accent1"/>
+            </a:effectRef>
+            <a:fontRef idx="minor">
+              <a:schemeClr val="tx1"/>
+            </a:fontRef>
+          </p:style>
+        </p:cxnSp>
+        <p:sp>
+          <p:nvSpPr>
+            <p:cNvPr id="17" name="文字方塊 16">
+              <a:extLst>
+                <a:ext uri="{FF2B5EF4-FFF2-40B4-BE49-F238E27FC236}">
+                  <a16:creationId xmlns:a16="http://schemas.microsoft.com/office/drawing/2014/main" id="{A2286F52-F14D-2E59-7502-658EDE17413F}"/>
+                </a:ext>
+              </a:extLst>
+            </p:cNvPr>
+            <p:cNvSpPr txBox="1"/>
+            <p:nvPr/>
+          </p:nvSpPr>
+          <p:spPr>
+            <a:xfrm>
+              <a:off x="4082244" y="5325684"/>
+              <a:ext cx="949449" cy="461665"/>
+            </a:xfrm>
+            <a:prstGeom prst="rect">
+              <a:avLst/>
+            </a:prstGeom>
+            <a:solidFill>
+              <a:schemeClr val="bg1"/>
+            </a:solidFill>
+          </p:spPr>
+          <p:txBody>
+            <a:bodyPr wrap="square" rtlCol="0" anchor="ctr">
+              <a:spAutoFit/>
+            </a:bodyPr>
+            <a:lstStyle/>
+            <a:p>
+              <a:pPr algn="ctr"/>
+              <a:r>
+                <a:rPr lang="en-US" altLang="zh-TW" sz="2400" dirty="0">
+                  <a:latin typeface="Calibri" panose="020F0502020204030204" pitchFamily="34" charset="0"/>
+                  <a:ea typeface="Calibri" panose="020F0502020204030204" pitchFamily="34" charset="0"/>
+                  <a:cs typeface="Calibri" panose="020F0502020204030204" pitchFamily="34" charset="0"/>
+                </a:rPr>
+                <a:t>2. CTS</a:t>
+              </a:r>
+              <a:endParaRPr lang="zh-TW" altLang="en-US" sz="2400" dirty="0">
+                <a:latin typeface="Calibri" panose="020F0502020204030204" pitchFamily="34" charset="0"/>
+                <a:ea typeface="Calibri" panose="020F0502020204030204" pitchFamily="34" charset="0"/>
+                <a:cs typeface="Calibri" panose="020F0502020204030204" pitchFamily="34" charset="0"/>
+              </a:endParaRPr>
+            </a:p>
+          </p:txBody>
+        </p:sp>
+      </p:grpSp>
+      <p:grpSp>
+        <p:nvGrpSpPr>
+          <p:cNvPr id="63" name="群組 62">
+            <a:extLst>
+              <a:ext uri="{FF2B5EF4-FFF2-40B4-BE49-F238E27FC236}">
+                <a16:creationId xmlns:a16="http://schemas.microsoft.com/office/drawing/2014/main" id="{A894F81D-9555-0AC5-7B6E-0370C4C47869}"/>
+              </a:ext>
+            </a:extLst>
+          </p:cNvPr>
+          <p:cNvGrpSpPr/>
+          <p:nvPr/>
+        </p:nvGrpSpPr>
+        <p:grpSpPr>
+          <a:xfrm>
+            <a:off x="4227750" y="5990763"/>
+            <a:ext cx="2196000" cy="461665"/>
+            <a:chOff x="3510115" y="5972176"/>
+            <a:chExt cx="2196000" cy="461665"/>
+          </a:xfrm>
+        </p:grpSpPr>
+        <p:cxnSp>
+          <p:nvCxnSpPr>
+            <p:cNvPr id="13" name="直線接點 12">
+              <a:extLst>
+                <a:ext uri="{FF2B5EF4-FFF2-40B4-BE49-F238E27FC236}">
+                  <a16:creationId xmlns:a16="http://schemas.microsoft.com/office/drawing/2014/main" id="{3334BB22-7ADE-EB72-D461-FAF49340B4DC}"/>
+                </a:ext>
+              </a:extLst>
+            </p:cNvPr>
+            <p:cNvCxnSpPr>
+              <a:cxnSpLocks/>
+            </p:cNvCxnSpPr>
+            <p:nvPr/>
+          </p:nvCxnSpPr>
+          <p:spPr>
+            <a:xfrm>
+              <a:off x="3510115" y="6203000"/>
+              <a:ext cx="2196000" cy="0"/>
+            </a:xfrm>
+            <a:prstGeom prst="line">
+              <a:avLst/>
+            </a:prstGeom>
+            <a:ln w="19050">
+              <a:solidFill>
+                <a:schemeClr val="tx1"/>
+              </a:solidFill>
+              <a:prstDash val="dash"/>
+              <a:headEnd type="none" w="med" len="med"/>
+              <a:tailEnd type="arrow" w="med" len="med"/>
+            </a:ln>
+          </p:spPr>
+          <p:style>
+            <a:lnRef idx="1">
+              <a:schemeClr val="accent1"/>
+            </a:lnRef>
+            <a:fillRef idx="0">
+              <a:schemeClr val="accent1"/>
+            </a:fillRef>
+            <a:effectRef idx="0">
+              <a:schemeClr val="accent1"/>
+            </a:effectRef>
+            <a:fontRef idx="minor">
+              <a:schemeClr val="tx1"/>
+            </a:fontRef>
+          </p:style>
+        </p:cxnSp>
+        <p:sp>
+          <p:nvSpPr>
+            <p:cNvPr id="18" name="文字方塊 17">
+              <a:extLst>
+                <a:ext uri="{FF2B5EF4-FFF2-40B4-BE49-F238E27FC236}">
+                  <a16:creationId xmlns:a16="http://schemas.microsoft.com/office/drawing/2014/main" id="{F3D52C2F-24EE-4F29-C2C6-A4EBE550A421}"/>
+                </a:ext>
+              </a:extLst>
+            </p:cNvPr>
+            <p:cNvSpPr txBox="1"/>
+            <p:nvPr/>
+          </p:nvSpPr>
+          <p:spPr>
+            <a:xfrm>
+              <a:off x="3850362" y="5972176"/>
+              <a:ext cx="1413213" cy="461665"/>
+            </a:xfrm>
+            <a:prstGeom prst="rect">
+              <a:avLst/>
+            </a:prstGeom>
+            <a:solidFill>
+              <a:schemeClr val="bg1"/>
+            </a:solidFill>
+          </p:spPr>
+          <p:txBody>
+            <a:bodyPr wrap="square" rtlCol="0" anchor="ctr">
+              <a:spAutoFit/>
+            </a:bodyPr>
+            <a:lstStyle/>
+            <a:p>
+              <a:pPr algn="ctr"/>
+              <a:r>
+                <a:rPr lang="en-US" altLang="zh-TW" sz="2400" dirty="0">
+                  <a:latin typeface="Calibri" panose="020F0502020204030204" pitchFamily="34" charset="0"/>
+                  <a:ea typeface="Calibri" panose="020F0502020204030204" pitchFamily="34" charset="0"/>
+                  <a:cs typeface="Calibri" panose="020F0502020204030204" pitchFamily="34" charset="0"/>
+                </a:rPr>
+                <a:t>3. DATA</a:t>
+              </a:r>
+              <a:endParaRPr lang="zh-TW" altLang="en-US" sz="2400" dirty="0">
+                <a:latin typeface="Calibri" panose="020F0502020204030204" pitchFamily="34" charset="0"/>
+                <a:ea typeface="Calibri" panose="020F0502020204030204" pitchFamily="34" charset="0"/>
+                <a:cs typeface="Calibri" panose="020F0502020204030204" pitchFamily="34" charset="0"/>
+              </a:endParaRPr>
+            </a:p>
+          </p:txBody>
+        </p:sp>
+      </p:grpSp>
+      <p:grpSp>
+        <p:nvGrpSpPr>
+          <p:cNvPr id="24" name="群組 23">
+            <a:extLst>
+              <a:ext uri="{FF2B5EF4-FFF2-40B4-BE49-F238E27FC236}">
+                <a16:creationId xmlns:a16="http://schemas.microsoft.com/office/drawing/2014/main" id="{574CB0A6-0408-B210-82D7-66FED1EA8C97}"/>
+              </a:ext>
+            </a:extLst>
+          </p:cNvPr>
+          <p:cNvGrpSpPr/>
+          <p:nvPr/>
+        </p:nvGrpSpPr>
+        <p:grpSpPr>
+          <a:xfrm>
+            <a:off x="8021922" y="5387544"/>
+            <a:ext cx="2510966" cy="461665"/>
+            <a:chOff x="7740307" y="5313936"/>
+            <a:chExt cx="2169268" cy="461665"/>
+          </a:xfrm>
+        </p:grpSpPr>
+        <p:cxnSp>
+          <p:nvCxnSpPr>
+            <p:cNvPr id="10" name="直線接點 9">
+              <a:extLst>
+                <a:ext uri="{FF2B5EF4-FFF2-40B4-BE49-F238E27FC236}">
+                  <a16:creationId xmlns:a16="http://schemas.microsoft.com/office/drawing/2014/main" id="{9F5A3781-6CD8-061D-B188-1C866BCEEAE0}"/>
+                </a:ext>
+              </a:extLst>
+            </p:cNvPr>
+            <p:cNvCxnSpPr>
+              <a:cxnSpLocks/>
+            </p:cNvCxnSpPr>
+            <p:nvPr/>
+          </p:nvCxnSpPr>
+          <p:spPr>
+            <a:xfrm>
+              <a:off x="7740307" y="5544769"/>
+              <a:ext cx="2169268" cy="8621"/>
+            </a:xfrm>
+            <a:prstGeom prst="line">
+              <a:avLst/>
+            </a:prstGeom>
+            <a:ln w="19050">
+              <a:solidFill>
+                <a:schemeClr val="tx1"/>
+              </a:solidFill>
+              <a:prstDash val="dash"/>
+              <a:headEnd type="none" w="med" len="med"/>
+              <a:tailEnd type="triangle" w="med" len="med"/>
+            </a:ln>
+          </p:spPr>
+          <p:style>
+            <a:lnRef idx="1">
+              <a:schemeClr val="accent1"/>
+            </a:lnRef>
+            <a:fillRef idx="0">
+              <a:schemeClr val="accent1"/>
+            </a:fillRef>
+            <a:effectRef idx="0">
+              <a:schemeClr val="accent1"/>
+            </a:effectRef>
+            <a:fontRef idx="minor">
+              <a:schemeClr val="tx1"/>
+            </a:fontRef>
+          </p:style>
+        </p:cxnSp>
+        <p:sp>
+          <p:nvSpPr>
+            <p:cNvPr id="20" name="文字方塊 19">
+              <a:extLst>
+                <a:ext uri="{FF2B5EF4-FFF2-40B4-BE49-F238E27FC236}">
+                  <a16:creationId xmlns:a16="http://schemas.microsoft.com/office/drawing/2014/main" id="{306246AA-E294-228B-2264-6FE8B56B1AAB}"/>
+                </a:ext>
+              </a:extLst>
+            </p:cNvPr>
+            <p:cNvSpPr txBox="1"/>
+            <p:nvPr/>
+          </p:nvSpPr>
+          <p:spPr>
+            <a:xfrm>
+              <a:off x="8396171" y="5313936"/>
+              <a:ext cx="1002848" cy="461665"/>
+            </a:xfrm>
+            <a:prstGeom prst="rect">
+              <a:avLst/>
+            </a:prstGeom>
+            <a:solidFill>
+              <a:schemeClr val="bg1"/>
+            </a:solidFill>
+          </p:spPr>
+          <p:txBody>
+            <a:bodyPr wrap="square" rtlCol="0" anchor="ctr">
+              <a:spAutoFit/>
+            </a:bodyPr>
+            <a:lstStyle/>
+            <a:p>
+              <a:pPr algn="ctr"/>
+              <a:r>
+                <a:rPr lang="en-US" altLang="zh-TW" sz="2400" dirty="0">
+                  <a:latin typeface="Calibri" panose="020F0502020204030204" pitchFamily="34" charset="0"/>
+                  <a:ea typeface="Calibri" panose="020F0502020204030204" pitchFamily="34" charset="0"/>
+                  <a:cs typeface="Calibri" panose="020F0502020204030204" pitchFamily="34" charset="0"/>
+                </a:rPr>
+                <a:t>2. CTS</a:t>
+              </a:r>
+              <a:endParaRPr lang="zh-TW" altLang="en-US" sz="2400" dirty="0">
+                <a:latin typeface="Calibri" panose="020F0502020204030204" pitchFamily="34" charset="0"/>
+                <a:ea typeface="Calibri" panose="020F0502020204030204" pitchFamily="34" charset="0"/>
+                <a:cs typeface="Calibri" panose="020F0502020204030204" pitchFamily="34" charset="0"/>
+              </a:endParaRPr>
+            </a:p>
+          </p:txBody>
+        </p:sp>
+      </p:grpSp>
+      <p:sp>
+        <p:nvSpPr>
+          <p:cNvPr id="27" name="文字方塊 26">
+            <a:extLst>
+              <a:ext uri="{FF2B5EF4-FFF2-40B4-BE49-F238E27FC236}">
+                <a16:creationId xmlns:a16="http://schemas.microsoft.com/office/drawing/2014/main" id="{D15F7617-31D0-6A13-9354-34064B37185E}"/>
+              </a:ext>
+            </a:extLst>
+          </p:cNvPr>
+          <p:cNvSpPr txBox="1"/>
+          <p:nvPr/>
+        </p:nvSpPr>
+        <p:spPr>
+          <a:xfrm>
+            <a:off x="2879585" y="4433469"/>
+            <a:ext cx="1592124" cy="461665"/>
+          </a:xfrm>
+          <a:prstGeom prst="rect">
+            <a:avLst/>
+          </a:prstGeom>
+          <a:noFill/>
+        </p:spPr>
+        <p:txBody>
+          <a:bodyPr wrap="square" rtlCol="0" anchor="ctr">
+            <a:spAutoFit/>
+          </a:bodyPr>
+          <a:lstStyle/>
+          <a:p>
+            <a:pPr algn="ctr"/>
+            <a:r>
+              <a:rPr lang="en-US" altLang="zh-TW" sz="2400" dirty="0">
+                <a:latin typeface="Calibri" panose="020F0502020204030204" pitchFamily="34" charset="0"/>
+                <a:ea typeface="Calibri" panose="020F0502020204030204" pitchFamily="34" charset="0"/>
+                <a:cs typeface="Calibri" panose="020F0502020204030204" pitchFamily="34" charset="0"/>
+              </a:rPr>
+              <a:t>Sender</a:t>
+            </a:r>
+            <a:endParaRPr lang="zh-TW" altLang="en-US" sz="2400" dirty="0">
+              <a:latin typeface="Calibri" panose="020F0502020204030204" pitchFamily="34" charset="0"/>
+              <a:ea typeface="Calibri" panose="020F0502020204030204" pitchFamily="34" charset="0"/>
+              <a:cs typeface="Calibri" panose="020F0502020204030204" pitchFamily="34" charset="0"/>
+            </a:endParaRPr>
+          </a:p>
+        </p:txBody>
+      </p:sp>
+      <p:sp>
+        <p:nvSpPr>
+          <p:cNvPr id="29" name="文字方塊 28">
+            <a:extLst>
+              <a:ext uri="{FF2B5EF4-FFF2-40B4-BE49-F238E27FC236}">
+                <a16:creationId xmlns:a16="http://schemas.microsoft.com/office/drawing/2014/main" id="{25B388D5-FA91-C7A0-E079-5EF72AF8B4A9}"/>
+              </a:ext>
+            </a:extLst>
+          </p:cNvPr>
+          <p:cNvSpPr txBox="1"/>
+          <p:nvPr/>
+        </p:nvSpPr>
+        <p:spPr>
+          <a:xfrm>
+            <a:off x="6474461" y="4419819"/>
+            <a:ext cx="1592124" cy="461665"/>
+          </a:xfrm>
+          <a:prstGeom prst="rect">
+            <a:avLst/>
+          </a:prstGeom>
+          <a:noFill/>
+        </p:spPr>
+        <p:txBody>
+          <a:bodyPr wrap="square" rtlCol="0" anchor="ctr">
+            <a:spAutoFit/>
+          </a:bodyPr>
+          <a:lstStyle/>
+          <a:p>
+            <a:pPr algn="ctr"/>
+            <a:r>
+              <a:rPr lang="en-US" altLang="zh-TW" sz="2400" dirty="0">
+                <a:latin typeface="Calibri" panose="020F0502020204030204" pitchFamily="34" charset="0"/>
+                <a:ea typeface="Calibri" panose="020F0502020204030204" pitchFamily="34" charset="0"/>
+                <a:cs typeface="Calibri" panose="020F0502020204030204" pitchFamily="34" charset="0"/>
+              </a:rPr>
+              <a:t>AP</a:t>
+            </a:r>
+            <a:endParaRPr lang="zh-TW" altLang="en-US" sz="2400" dirty="0">
+              <a:latin typeface="Calibri" panose="020F0502020204030204" pitchFamily="34" charset="0"/>
+              <a:ea typeface="Calibri" panose="020F0502020204030204" pitchFamily="34" charset="0"/>
+              <a:cs typeface="Calibri" panose="020F0502020204030204" pitchFamily="34" charset="0"/>
+            </a:endParaRPr>
+          </a:p>
+        </p:txBody>
+      </p:sp>
+      <p:sp>
+        <p:nvSpPr>
+          <p:cNvPr id="31" name="文字方塊 30">
+            <a:extLst>
+              <a:ext uri="{FF2B5EF4-FFF2-40B4-BE49-F238E27FC236}">
+                <a16:creationId xmlns:a16="http://schemas.microsoft.com/office/drawing/2014/main" id="{5BE80359-67D1-51E9-E7F7-FB94D7F10C68}"/>
+              </a:ext>
+            </a:extLst>
+          </p:cNvPr>
+          <p:cNvSpPr txBox="1"/>
+          <p:nvPr/>
+        </p:nvSpPr>
+        <p:spPr>
+          <a:xfrm>
+            <a:off x="9831912" y="4323740"/>
+            <a:ext cx="2168744" cy="461665"/>
+          </a:xfrm>
+          <a:prstGeom prst="rect">
+            <a:avLst/>
+          </a:prstGeom>
+          <a:noFill/>
+        </p:spPr>
+        <p:txBody>
+          <a:bodyPr wrap="square" rtlCol="0" anchor="ctr">
+            <a:spAutoFit/>
+          </a:bodyPr>
+          <a:lstStyle/>
+          <a:p>
+            <a:pPr algn="ctr"/>
+            <a:r>
+              <a:rPr lang="en-US" altLang="zh-TW" sz="2400" dirty="0">
+                <a:latin typeface="Calibri" panose="020F0502020204030204" pitchFamily="34" charset="0"/>
+                <a:ea typeface="Calibri" panose="020F0502020204030204" pitchFamily="34" charset="0"/>
+                <a:cs typeface="Calibri" panose="020F0502020204030204" pitchFamily="34" charset="0"/>
+              </a:rPr>
+              <a:t>Hidden Node</a:t>
+            </a:r>
+            <a:endParaRPr lang="zh-TW" altLang="en-US" sz="2400" dirty="0">
+              <a:latin typeface="Calibri" panose="020F0502020204030204" pitchFamily="34" charset="0"/>
+              <a:ea typeface="Calibri" panose="020F0502020204030204" pitchFamily="34" charset="0"/>
+              <a:cs typeface="Calibri" panose="020F0502020204030204" pitchFamily="34" charset="0"/>
+            </a:endParaRPr>
+          </a:p>
+        </p:txBody>
+      </p:sp>
+      <p:pic>
+        <p:nvPicPr>
+          <p:cNvPr id="65" name="內容版面配置區 5">
+            <a:extLst>
+              <a:ext uri="{FF2B5EF4-FFF2-40B4-BE49-F238E27FC236}">
+                <a16:creationId xmlns:a16="http://schemas.microsoft.com/office/drawing/2014/main" id="{DB9FAEA5-1EC1-5A07-00D6-CF7D2B0760A9}"/>
+              </a:ext>
+            </a:extLst>
+          </p:cNvPr>
+          <p:cNvPicPr>
+            <a:picLocks noChangeAspect="1"/>
+          </p:cNvPicPr>
+          <p:nvPr/>
+        </p:nvPicPr>
+        <p:blipFill>
+          <a:blip r:embed="rId3">
+            <a:extLst>
+              <a:ext uri="{28A0092B-C50C-407E-A947-70E740481C1C}">
+                <a14:useLocalDpi xmlns:a14="http://schemas.microsoft.com/office/drawing/2010/main" val="0"/>
+              </a:ext>
+            </a:extLst>
+          </a:blip>
+          <a:stretch>
+            <a:fillRect/>
+          </a:stretch>
+        </p:blipFill>
+        <p:spPr>
+          <a:xfrm>
+            <a:off x="-259180" y="4785405"/>
+            <a:ext cx="1592125" cy="1592125"/>
+          </a:xfrm>
+          <a:prstGeom prst="rect">
+            <a:avLst/>
+          </a:prstGeom>
+          <a:noFill/>
+        </p:spPr>
+      </p:pic>
+      <p:grpSp>
+        <p:nvGrpSpPr>
+          <p:cNvPr id="69" name="群組 68">
+            <a:extLst>
+              <a:ext uri="{FF2B5EF4-FFF2-40B4-BE49-F238E27FC236}">
+                <a16:creationId xmlns:a16="http://schemas.microsoft.com/office/drawing/2014/main" id="{81E715B8-4FA9-7848-A70B-58B56E527FAB}"/>
+              </a:ext>
+            </a:extLst>
+          </p:cNvPr>
+          <p:cNvGrpSpPr/>
+          <p:nvPr/>
+        </p:nvGrpSpPr>
+        <p:grpSpPr>
+          <a:xfrm>
+            <a:off x="4227040" y="4830100"/>
+            <a:ext cx="2197420" cy="461665"/>
+            <a:chOff x="3434887" y="4679193"/>
+            <a:chExt cx="2197420" cy="461665"/>
+          </a:xfrm>
+        </p:grpSpPr>
+        <p:cxnSp>
+          <p:nvCxnSpPr>
+            <p:cNvPr id="70" name="直線接點 69">
+              <a:extLst>
+                <a:ext uri="{FF2B5EF4-FFF2-40B4-BE49-F238E27FC236}">
+                  <a16:creationId xmlns:a16="http://schemas.microsoft.com/office/drawing/2014/main" id="{FDC67D34-43FE-0D54-4111-58FFF1951312}"/>
+                </a:ext>
+              </a:extLst>
+            </p:cNvPr>
+            <p:cNvCxnSpPr>
+              <a:cxnSpLocks/>
+            </p:cNvCxnSpPr>
+            <p:nvPr/>
+          </p:nvCxnSpPr>
+          <p:spPr>
+            <a:xfrm>
+              <a:off x="3434887" y="4910017"/>
+              <a:ext cx="2197420" cy="0"/>
+            </a:xfrm>
+            <a:prstGeom prst="line">
+              <a:avLst/>
+            </a:prstGeom>
+            <a:ln w="19050">
+              <a:solidFill>
+                <a:schemeClr val="tx1"/>
+              </a:solidFill>
+              <a:prstDash val="dash"/>
+              <a:headEnd type="none" w="med" len="med"/>
+              <a:tailEnd type="arrow" w="med" len="med"/>
+            </a:ln>
+          </p:spPr>
+          <p:style>
+            <a:lnRef idx="1">
+              <a:schemeClr val="accent1"/>
+            </a:lnRef>
+            <a:fillRef idx="0">
+              <a:schemeClr val="accent1"/>
+            </a:fillRef>
+            <a:effectRef idx="0">
+              <a:schemeClr val="accent1"/>
+            </a:effectRef>
+            <a:fontRef idx="minor">
+              <a:schemeClr val="tx1"/>
+            </a:fontRef>
+          </p:style>
+        </p:cxnSp>
+        <p:sp>
+          <p:nvSpPr>
+            <p:cNvPr id="71" name="文字方塊 70">
+              <a:extLst>
+                <a:ext uri="{FF2B5EF4-FFF2-40B4-BE49-F238E27FC236}">
+                  <a16:creationId xmlns:a16="http://schemas.microsoft.com/office/drawing/2014/main" id="{866A48AF-D1AE-BE7D-456D-2CA0DE8E508C}"/>
+                </a:ext>
+              </a:extLst>
+            </p:cNvPr>
+            <p:cNvSpPr txBox="1"/>
+            <p:nvPr/>
+          </p:nvSpPr>
+          <p:spPr>
+            <a:xfrm>
+              <a:off x="4082244" y="4679193"/>
+              <a:ext cx="949449" cy="461665"/>
+            </a:xfrm>
+            <a:prstGeom prst="rect">
+              <a:avLst/>
+            </a:prstGeom>
+            <a:solidFill>
+              <a:schemeClr val="bg1"/>
+            </a:solidFill>
+          </p:spPr>
+          <p:txBody>
+            <a:bodyPr wrap="square" rtlCol="0" anchor="ctr">
+              <a:spAutoFit/>
+            </a:bodyPr>
+            <a:lstStyle/>
+            <a:p>
+              <a:pPr algn="ctr"/>
+              <a:r>
+                <a:rPr lang="en-US" altLang="zh-TW" sz="2400" dirty="0">
+                  <a:latin typeface="Calibri" panose="020F0502020204030204" pitchFamily="34" charset="0"/>
+                  <a:ea typeface="Calibri" panose="020F0502020204030204" pitchFamily="34" charset="0"/>
+                  <a:cs typeface="Calibri" panose="020F0502020204030204" pitchFamily="34" charset="0"/>
+                </a:rPr>
+                <a:t>1. RTS</a:t>
+              </a:r>
+              <a:endParaRPr lang="zh-TW" altLang="en-US" sz="2400" dirty="0">
+                <a:latin typeface="Calibri" panose="020F0502020204030204" pitchFamily="34" charset="0"/>
+                <a:ea typeface="Calibri" panose="020F0502020204030204" pitchFamily="34" charset="0"/>
+                <a:cs typeface="Calibri" panose="020F0502020204030204" pitchFamily="34" charset="0"/>
+              </a:endParaRPr>
+            </a:p>
+          </p:txBody>
+        </p:sp>
+      </p:grpSp>
+      <p:sp>
+        <p:nvSpPr>
+          <p:cNvPr id="73" name="文字方塊 72">
+            <a:extLst>
+              <a:ext uri="{FF2B5EF4-FFF2-40B4-BE49-F238E27FC236}">
+                <a16:creationId xmlns:a16="http://schemas.microsoft.com/office/drawing/2014/main" id="{04C15B66-6828-4C06-F554-AD0DAF2EDB35}"/>
+              </a:ext>
+            </a:extLst>
+          </p:cNvPr>
+          <p:cNvSpPr txBox="1"/>
+          <p:nvPr/>
+        </p:nvSpPr>
+        <p:spPr>
+          <a:xfrm>
+            <a:off x="690284" y="5661953"/>
+            <a:ext cx="1647605" cy="830997"/>
+          </a:xfrm>
+          <a:prstGeom prst="rect">
+            <a:avLst/>
+          </a:prstGeom>
+          <a:noFill/>
+        </p:spPr>
+        <p:txBody>
+          <a:bodyPr wrap="square" rtlCol="0" anchor="ctr">
+            <a:spAutoFit/>
+          </a:bodyPr>
+          <a:lstStyle/>
+          <a:p>
+            <a:pPr algn="ctr"/>
+            <a:r>
+              <a:rPr lang="en-US" altLang="zh-TW" sz="2400" dirty="0">
+                <a:latin typeface="Calibri" panose="020F0502020204030204" pitchFamily="34" charset="0"/>
+                <a:ea typeface="Calibri" panose="020F0502020204030204" pitchFamily="34" charset="0"/>
+                <a:cs typeface="Calibri" panose="020F0502020204030204" pitchFamily="34" charset="0"/>
+              </a:rPr>
+              <a:t>Nearby</a:t>
+            </a:r>
+            <a:br>
+              <a:rPr lang="en-US" altLang="zh-TW" sz="2400" dirty="0">
+                <a:latin typeface="Calibri" panose="020F0502020204030204" pitchFamily="34" charset="0"/>
+                <a:ea typeface="Calibri" panose="020F0502020204030204" pitchFamily="34" charset="0"/>
+                <a:cs typeface="Calibri" panose="020F0502020204030204" pitchFamily="34" charset="0"/>
+              </a:rPr>
+            </a:br>
+            <a:r>
+              <a:rPr lang="en-US" altLang="zh-TW" sz="2400" dirty="0">
+                <a:latin typeface="Calibri" panose="020F0502020204030204" pitchFamily="34" charset="0"/>
+                <a:ea typeface="Calibri" panose="020F0502020204030204" pitchFamily="34" charset="0"/>
+                <a:cs typeface="Calibri" panose="020F0502020204030204" pitchFamily="34" charset="0"/>
+              </a:rPr>
+              <a:t>Node</a:t>
+            </a:r>
+            <a:endParaRPr lang="zh-TW" altLang="en-US" sz="2400" dirty="0">
+              <a:latin typeface="Calibri" panose="020F0502020204030204" pitchFamily="34" charset="0"/>
+              <a:ea typeface="Calibri" panose="020F0502020204030204" pitchFamily="34" charset="0"/>
+              <a:cs typeface="Calibri" panose="020F0502020204030204" pitchFamily="34" charset="0"/>
+            </a:endParaRPr>
+          </a:p>
+        </p:txBody>
+      </p:sp>
+      <p:sp>
+        <p:nvSpPr>
+          <p:cNvPr id="75" name="乘號 74">
+            <a:extLst>
+              <a:ext uri="{FF2B5EF4-FFF2-40B4-BE49-F238E27FC236}">
+                <a16:creationId xmlns:a16="http://schemas.microsoft.com/office/drawing/2014/main" id="{A3FAB8E5-1165-21A0-248D-352EAA57EC28}"/>
+              </a:ext>
+            </a:extLst>
+          </p:cNvPr>
+          <p:cNvSpPr/>
+          <p:nvPr/>
+        </p:nvSpPr>
+        <p:spPr bwMode="auto">
+          <a:xfrm>
+            <a:off x="-134895" y="4433469"/>
+            <a:ext cx="914400" cy="914400"/>
+          </a:xfrm>
+          <a:prstGeom prst="mathMultiply">
+            <a:avLst/>
+          </a:prstGeom>
+          <a:solidFill>
+            <a:srgbClr val="FF0000"/>
+          </a:solidFill>
+          <a:ln w="9525" cap="flat" cmpd="sng" algn="ctr">
+            <a:solidFill>
+              <a:schemeClr val="tx1"/>
+            </a:solidFill>
+            <a:prstDash val="solid"/>
+            <a:round/>
+            <a:headEnd type="none" w="med" len="med"/>
+            <a:tailEnd type="none" w="med" len="med"/>
+          </a:ln>
+          <a:effectLst/>
+        </p:spPr>
+        <p:txBody>
+          <a:bodyPr vert="horz" wrap="square" lIns="91440" tIns="45720" rIns="91440" bIns="45720" numCol="1" rtlCol="0" anchor="t" anchorCtr="0" compatLnSpc="1">
+            <a:prstTxWarp prst="textNoShape">
+              <a:avLst/>
+            </a:prstTxWarp>
+          </a:bodyPr>
+          <a:lstStyle/>
+          <a:p>
+            <a:pPr marL="0" marR="0" indent="0" algn="l" defTabSz="914400" rtl="0" eaLnBrk="1" fontAlgn="base" latinLnBrk="0" hangingPunct="1">
+              <a:lnSpc>
+                <a:spcPct val="100000"/>
+              </a:lnSpc>
+              <a:spcBef>
+                <a:spcPct val="0"/>
+              </a:spcBef>
+              <a:spcAft>
+                <a:spcPct val="0"/>
+              </a:spcAft>
+              <a:buClrTx/>
+              <a:buSzTx/>
+              <a:buFontTx/>
+              <a:buNone/>
+              <a:tabLst/>
+            </a:pPr>
+            <a:endParaRPr kumimoji="1" lang="zh-TW" altLang="en-US" sz="3600" b="0" i="0" u="none" strike="noStrike" cap="none" normalizeH="0" baseline="0">
+              <a:ln>
+                <a:noFill/>
+              </a:ln>
+              <a:solidFill>
+                <a:schemeClr val="tx2"/>
+              </a:solidFill>
+              <a:effectLst/>
+              <a:latin typeface="Times New Roman" pitchFamily="18" charset="0"/>
+              <a:ea typeface="標楷體" pitchFamily="65" charset="-120"/>
+            </a:endParaRPr>
+          </a:p>
+        </p:txBody>
+      </p:sp>
     </p:spTree>
     <p:extLst>
       <p:ext uri="{BB962C8B-B14F-4D97-AF65-F5344CB8AC3E}">
@@ -13639,8 +15946,8 @@
           <a:lstStyle/>
           <a:p>
             <a:r>
-              <a:rPr lang="zh-TW" altLang="zh-TW" dirty="0"/>
-              <a:t>Static RTS Thresholds Cannot Track Hidden-Node Risk</a:t>
+              <a:rPr lang="en-US" altLang="zh-TW" dirty="0"/>
+              <a:t>Limitations of Static RTS Thresholds</a:t>
             </a:r>
             <a:endParaRPr lang="zh-TW" altLang="en-US" dirty="0"/>
           </a:p>
@@ -13669,16 +15976,15 @@
           <a:p>
             <a:r>
               <a:rPr lang="zh-TW" altLang="zh-TW" dirty="0"/>
-              <a:t>Conventional 802.11 usually uses a fixed RTS threshold.</a:t>
+              <a:t>Conventional 802.11 usually uses a fixed RTS threshold</a:t>
             </a:r>
             <a:endParaRPr lang="en-US" altLang="zh-TW" dirty="0"/>
           </a:p>
           <a:p>
             <a:r>
               <a:rPr lang="zh-TW" altLang="zh-TW" dirty="0"/>
-              <a:t>A fixed threshold cannot adapt to station location or changing hidden-node conditions.</a:t>
-            </a:r>
-            <a:endParaRPr lang="zh-TW" altLang="en-US" dirty="0"/>
+              <a:t>A static threshold cannot adapt to changing node locations</a:t>
+            </a:r>
           </a:p>
         </p:txBody>
       </p:sp>
@@ -13774,9 +16080,14 @@
           <a:lstStyle/>
           <a:p>
             <a:r>
-              <a:rPr dirty="0"/>
-              <a:t>Hidden-Node Risk-Aware RTS Threshold Control</a:t>
-            </a:r>
+              <a:rPr lang="zh-TW" altLang="zh-TW" dirty="0"/>
+              <a:t>Spatially Aware Dynamic RTS Threshold Using</a:t>
+            </a:r>
+            <a:r>
+              <a:rPr lang="en-US" altLang="zh-TW" dirty="0"/>
+              <a:t> AoA</a:t>
+            </a:r>
+            <a:endParaRPr lang="zh-TW" altLang="zh-TW" dirty="0"/>
           </a:p>
         </p:txBody>
       </p:sp>
@@ -13802,9 +16113,38 @@
           <a:lstStyle/>
           <a:p>
             <a:r>
-              <a:rPr dirty="0"/>
-              <a:t>The AP infers hidden-node risk from Angle of Arrival (AoA) and link observations, then tunes the RTS threshold dynamically.</a:t>
-            </a:r>
+              <a:rPr lang="zh-TW" altLang="zh-TW" dirty="0"/>
+              <a:t>AoA provides spatial cues about the relative directions of stations</a:t>
+            </a:r>
+          </a:p>
+          <a:p>
+            <a:r>
+              <a:rPr lang="zh-TW" altLang="zh-TW" dirty="0"/>
+              <a:t>AP combines AoA with link information</a:t>
+            </a:r>
+            <a:r>
+              <a:rPr lang="en-US" altLang="zh-TW" dirty="0"/>
+              <a:t> </a:t>
+            </a:r>
+            <a:r>
+              <a:rPr lang="zh-TW" altLang="zh-TW" dirty="0"/>
+              <a:t>to estimate hidden-node risk</a:t>
+            </a:r>
+          </a:p>
+          <a:p>
+            <a:r>
+              <a:rPr lang="en-US" altLang="zh-TW" dirty="0"/>
+              <a:t>E</a:t>
+            </a:r>
+            <a:r>
+              <a:rPr lang="zh-TW" altLang="zh-TW" dirty="0"/>
+              <a:t>stimated risk guides dynamic RTS </a:t>
+            </a:r>
+            <a:r>
+              <a:rPr lang="zh-TW" altLang="zh-TW"/>
+              <a:t>threshold adjustment</a:t>
+            </a:r>
+            <a:endParaRPr lang="en-US" altLang="zh-TW" dirty="0"/>
           </a:p>
         </p:txBody>
       </p:sp>
@@ -13844,6 +16184,60 @@
               <a:latin typeface="Times New Roman"/>
               <a:ea typeface="Times New Roman"/>
               <a:cs typeface="Times New Roman"/>
+            </a:endParaRPr>
+          </a:p>
+        </p:txBody>
+      </p:sp>
+      <p:sp>
+        <p:nvSpPr>
+          <p:cNvPr id="5" name="文字方塊 4">
+            <a:extLst>
+              <a:ext uri="{FF2B5EF4-FFF2-40B4-BE49-F238E27FC236}">
+                <a16:creationId xmlns:a16="http://schemas.microsoft.com/office/drawing/2014/main" id="{C112E6F4-B8F3-66BC-DBB7-16D3CDCE5481}"/>
+              </a:ext>
+            </a:extLst>
+          </p:cNvPr>
+          <p:cNvSpPr txBox="1"/>
+          <p:nvPr/>
+        </p:nvSpPr>
+        <p:spPr>
+          <a:xfrm>
+            <a:off x="8421329" y="5928484"/>
+            <a:ext cx="3770671" cy="461665"/>
+          </a:xfrm>
+          <a:prstGeom prst="rect">
+            <a:avLst/>
+          </a:prstGeom>
+          <a:noFill/>
+        </p:spPr>
+        <p:txBody>
+          <a:bodyPr wrap="square" rtlCol="0" anchor="ctr">
+            <a:spAutoFit/>
+          </a:bodyPr>
+          <a:lstStyle/>
+          <a:p>
+            <a:pPr algn="ctr"/>
+            <a:r>
+              <a:rPr lang="zh-TW" altLang="zh-TW" sz="2400" dirty="0">
+                <a:solidFill>
+                  <a:schemeClr val="bg1">
+                    <a:lumMod val="50000"/>
+                  </a:schemeClr>
+                </a:solidFill>
+                <a:latin typeface="Calibri" panose="020F0502020204030204" pitchFamily="34" charset="0"/>
+                <a:cs typeface="Calibri" panose="020F0502020204030204" pitchFamily="34" charset="0"/>
+              </a:rPr>
+              <a:t>Angle of Arrival (AoA)</a:t>
+            </a:r>
+            <a:endParaRPr lang="zh-TW" altLang="en-US" sz="2400" dirty="0">
+              <a:solidFill>
+                <a:schemeClr val="bg1">
+                  <a:lumMod val="50000"/>
+                </a:schemeClr>
+              </a:solidFill>
+              <a:latin typeface="Calibri" panose="020F0502020204030204" pitchFamily="34" charset="0"/>
+              <a:ea typeface="Calibri" panose="020F0502020204030204" pitchFamily="34" charset="0"/>
+              <a:cs typeface="Calibri" panose="020F0502020204030204" pitchFamily="34" charset="0"/>
             </a:endParaRPr>
           </a:p>
         </p:txBody>
@@ -14185,7 +16579,7 @@
             <a:pPr lvl="1"/>
             <a:r>
               <a:rPr lang="en-US" altLang="zh-TW" dirty="0"/>
-              <a:t> therefore contains geometric information of the propagation space</a:t>
+              <a:t> Therefore, contains geometric information of the propagation space</a:t>
             </a:r>
           </a:p>
           <a:p>

</xml_diff>